<commit_message>
Merge logo slides, clarify attribute positioning, align compositions
Co-Authored-By: Claude Opus 5.5 <noreply@anthropic.com>
Claude-Session: https://claude.ai/code/session_01TPggK9YYJAqPjj1kZSx5tS
</commit_message>
<xml_diff>
--- a/Фотокорпус.pptx
+++ b/Фотокорпус.pptx
@@ -13,10 +13,9 @@
     <p:sldId id="261" r:id="rId7"/>
     <p:sldId id="262" r:id="rId8"/>
     <p:sldId id="263" r:id="rId9"/>
-    <p:sldId id="264" r:id="rId10"/>
   </p:sldIdLst>
   <p:notesMasterIdLst>
-    <p:notesMasterId r:id="rId11"/>
+    <p:notesMasterId r:id="rId10"/>
   </p:notesMasterIdLst>
   <p:sldSz cx="12192000" cy="6858000"/>
   <p:notesSz cx="6858000" cy="12192000"/>
@@ -115,12 +114,12 @@
   <p:extLst>
     <p:ext uri="{521415D9-36F7-43E2-AB2F-B90AF26B5E84}">
       <p14:sectionLst xmlns:p14="http://schemas.microsoft.com/office/powerpoint/2010/main">
-        <p14:section name="Титул" id="{a1ac6e9e-9791-5523-db79-9a3c3f91f2e1}">
+        <p14:section name="Титул" id="{63edea59-f11c-cf7e-1012-6ba9fe401794}">
           <p14:sldIdLst>
             <p14:sldId id="256"/>
           </p14:sldIdLst>
         </p14:section>
-        <p14:section name="Бизнес-модель" id="{dcdf5367-6dc9-1add-f837-599ad782b6e0}">
+        <p14:section name="Бизнес-модель" id="{e3a8e416-f186-72d3-501f-8ad79b237cac}">
           <p14:sldIdLst>
             <p14:sldId id="257"/>
             <p14:sldId id="258"/>
@@ -128,16 +127,15 @@
             <p14:sldId id="260"/>
           </p14:sldIdLst>
         </p14:section>
-        <p14:section name="Позиционирование" id="{cabb5140-9024-9ad8-9a71-5d11773533f0}">
+        <p14:section name="Позиционирование" id="{f8fdb223-538b-28aa-c8fe-7af248a470e9}">
           <p14:sldIdLst>
             <p14:sldId id="261"/>
           </p14:sldIdLst>
         </p14:section>
-        <p14:section name="Айдентика" id="{9ea71a7a-f349-5e81-54f2-ed4facdc4a7b}">
+        <p14:section name="Айдентика" id="{8e73d62e-3fb6-f357-12a3-ad468b70d003}">
           <p14:sldIdLst>
             <p14:sldId id="262"/>
             <p14:sldId id="263"/>
-            <p14:sldId id="264"/>
           </p14:sldIdLst>
         </p14:section>
       </p14:sectionLst>
@@ -1184,94 +1182,6 @@
             <a:fld id="{F7021451-1387-4CA6-816F-3879F97B5CBC}" type="slidenum">
               <a:rPr lang="en-US"/>
               <a:t>8</a:t>
-            </a:fld>
-            <a:endParaRPr lang="en-US"/>
-          </a:p>
-        </p:txBody>
-      </p:sp>
-    </p:spTree>
-    <p:extLst>
-      <p:ext uri="{BB962C8B-B14F-4D97-AF65-F5344CB8AC3E}">
-        <p14:creationId xmlns:p14="http://schemas.microsoft.com/office/powerpoint/2010/main" val="1024086991"/>
-      </p:ext>
-    </p:extLst>
-  </p:cSld>
-  <p:clrMapOvr>
-    <a:masterClrMapping/>
-  </p:clrMapOvr>
-</p:notes>
-</file>
-
-<file path=ppt/notesSlides/notesSlide9.xml><?xml version="1.0" encoding="utf-8"?>
-<p:notes xmlns:a="http://schemas.openxmlformats.org/drawingml/2006/main" xmlns:r="http://schemas.openxmlformats.org/officeDocument/2006/relationships" xmlns:p="http://schemas.openxmlformats.org/presentationml/2006/main">
-  <p:cSld>
-    <p:spTree>
-      <p:nvGrpSpPr>
-        <p:cNvPr id="1" name=""/>
-        <p:cNvGrpSpPr/>
-        <p:nvPr/>
-      </p:nvGrpSpPr>
-      <p:grpSpPr>
-        <a:xfrm>
-          <a:off x="0" y="0"/>
-          <a:ext cx="0" cy="0"/>
-          <a:chOff x="0" y="0"/>
-          <a:chExt cx="0" cy="0"/>
-        </a:xfrm>
-      </p:grpSpPr>
-      <p:sp>
-        <p:nvSpPr>
-          <p:cNvPr id="2" name="Slide Image Placeholder 1"/>
-          <p:cNvSpPr>
-            <a:spLocks noGrp="1" noRot="1" noChangeAspect="1"/>
-          </p:cNvSpPr>
-          <p:nvPr>
-            <p:ph type="sldImg"/>
-          </p:nvPr>
-        </p:nvSpPr>
-        <p:spPr/>
-      </p:sp>
-      <p:sp>
-        <p:nvSpPr>
-          <p:cNvPr id="3" name="Notes Placeholder 2"/>
-          <p:cNvSpPr>
-            <a:spLocks noGrp="1"/>
-          </p:cNvSpPr>
-          <p:nvPr>
-            <p:ph type="body" idx="1"/>
-          </p:nvPr>
-        </p:nvSpPr>
-        <p:spPr/>
-        <p:txBody>
-          <a:bodyPr/>
-          <a:lstStyle/>
-          <a:p>
-            <a:r>
-              <a:rPr lang="en-US" dirty="0"/>
-              <a:t/>
-            </a:r>
-            <a:endParaRPr lang="en-US" dirty="0"/>
-          </a:p>
-        </p:txBody>
-      </p:sp>
-      <p:sp>
-        <p:nvSpPr>
-          <p:cNvPr id="4" name="Slide Number Placeholder 3"/>
-          <p:cNvSpPr>
-            <a:spLocks noGrp="1"/>
-          </p:cNvSpPr>
-          <p:nvPr>
-            <p:ph type="sldNum" sz="quarter" idx="10"/>
-          </p:nvPr>
-        </p:nvSpPr>
-        <p:spPr/>
-        <p:txBody>
-          <a:bodyPr/>
-          <a:lstStyle/>
-          <a:p>
-            <a:fld id="{F7021451-1387-4CA6-816F-3879F97B5CBC}" type="slidenum">
-              <a:rPr lang="en-US"/>
-              <a:t>9</a:t>
             </a:fld>
             <a:endParaRPr lang="en-US"/>
           </a:p>
@@ -1906,7 +1816,7 @@
         </p:blipFill>
         <p:spPr>
           <a:xfrm>
-            <a:off x="512064" y="960120"/>
+            <a:off x="512064" y="1234440"/>
             <a:ext cx="7132320" cy="933511"/>
           </a:xfrm>
           <a:prstGeom prst="rect">
@@ -1922,7 +1832,7 @@
         </p:nvSpPr>
         <p:spPr>
           <a:xfrm>
-            <a:off x="548640" y="2103120"/>
+            <a:off x="548640" y="2514600"/>
             <a:ext cx="7772400" cy="685800"/>
           </a:xfrm>
           <a:prstGeom prst="rect">
@@ -1961,7 +1871,7 @@
         </p:nvSpPr>
         <p:spPr>
           <a:xfrm>
-            <a:off x="548640" y="2880360"/>
+            <a:off x="548640" y="3337560"/>
             <a:ext cx="8229600" cy="457200"/>
           </a:xfrm>
           <a:prstGeom prst="rect">
@@ -2630,7 +2540,7 @@
           <a:ln/>
         </p:spPr>
         <p:txBody>
-          <a:bodyPr wrap="square" lIns="0" tIns="0" rIns="0" bIns="0" rtlCol="0" anchor="b"/>
+          <a:bodyPr wrap="square" lIns="0" tIns="0" rIns="0" bIns="0" rtlCol="0" anchor="t"/>
           <a:lstStyle/>
           <a:p>
             <a:pPr indent="0" marL="0">
@@ -2755,7 +2665,7 @@
           <a:ln/>
         </p:spPr>
         <p:txBody>
-          <a:bodyPr wrap="square" lIns="0" tIns="0" rIns="0" bIns="0" rtlCol="0" anchor="b"/>
+          <a:bodyPr wrap="square" lIns="0" tIns="0" rIns="0" bIns="0" rtlCol="0" anchor="t"/>
           <a:lstStyle/>
           <a:p>
             <a:pPr indent="0" marL="0">
@@ -2880,7 +2790,7 @@
           <a:ln/>
         </p:spPr>
         <p:txBody>
-          <a:bodyPr wrap="square" lIns="0" tIns="0" rIns="0" bIns="0" rtlCol="0" anchor="b"/>
+          <a:bodyPr wrap="square" lIns="0" tIns="0" rIns="0" bIns="0" rtlCol="0" anchor="t"/>
           <a:lstStyle/>
           <a:p>
             <a:pPr indent="0" marL="0">
@@ -3005,7 +2915,7 @@
           <a:ln/>
         </p:spPr>
         <p:txBody>
-          <a:bodyPr wrap="square" lIns="0" tIns="0" rIns="0" bIns="0" rtlCol="0" anchor="b"/>
+          <a:bodyPr wrap="square" lIns="0" tIns="0" rIns="0" bIns="0" rtlCol="0" anchor="t"/>
           <a:lstStyle/>
           <a:p>
             <a:pPr indent="0" marL="0">
@@ -3130,7 +3040,7 @@
           <a:ln/>
         </p:spPr>
         <p:txBody>
-          <a:bodyPr wrap="square" lIns="0" tIns="0" rIns="0" bIns="0" rtlCol="0" anchor="b"/>
+          <a:bodyPr wrap="square" lIns="0" tIns="0" rIns="0" bIns="0" rtlCol="0" anchor="t"/>
           <a:lstStyle/>
           <a:p>
             <a:pPr indent="0" marL="0">
@@ -3255,7 +3165,7 @@
           <a:ln/>
         </p:spPr>
         <p:txBody>
-          <a:bodyPr wrap="square" lIns="0" tIns="0" rIns="0" bIns="0" rtlCol="0" anchor="b"/>
+          <a:bodyPr wrap="square" lIns="0" tIns="0" rIns="0" bIns="0" rtlCol="0" anchor="t"/>
           <a:lstStyle/>
           <a:p>
             <a:pPr indent="0" marL="0">
@@ -4731,7 +4641,7 @@
                 <a:gridCol w="3154680"/>
                 <a:gridCol w="2316175"/>
               </a:tblGrid>
-              <a:tr h="347472">
+              <a:tr h="384048">
                 <a:tc>
                   <a:txBody>
                     <a:bodyPr/>
@@ -5005,7 +4915,7 @@
                   </a:tcPr>
                 </a:tc>
               </a:tr>
-              <a:tr h="731520">
+              <a:tr h="777240">
                 <a:tc>
                   <a:txBody>
                     <a:bodyPr/>
@@ -5321,7 +5231,7 @@
                   </a:tcPr>
                 </a:tc>
               </a:tr>
-              <a:tr h="731520">
+              <a:tr h="777240">
                 <a:tc>
                   <a:txBody>
                     <a:bodyPr/>
@@ -5637,7 +5547,7 @@
                   </a:tcPr>
                 </a:tc>
               </a:tr>
-              <a:tr h="566928">
+              <a:tr h="658368">
                 <a:tc>
                   <a:txBody>
                     <a:bodyPr/>
@@ -5932,7 +5842,7 @@
                   </a:tcPr>
                 </a:tc>
               </a:tr>
-              <a:tr h="731520">
+              <a:tr h="777240">
                 <a:tc>
                   <a:txBody>
                     <a:bodyPr/>
@@ -6227,7 +6137,7 @@
                   </a:tcPr>
                 </a:tc>
               </a:tr>
-              <a:tr h="566928">
+              <a:tr h="658368">
                 <a:tc>
                   <a:txBody>
                     <a:bodyPr/>
@@ -6534,8 +6444,8 @@
         </p:nvSpPr>
         <p:spPr>
           <a:xfrm>
-            <a:off x="548640" y="5760720"/>
-            <a:ext cx="10180015" cy="502920"/>
+            <a:off x="548640" y="5897880"/>
+            <a:ext cx="10180015" cy="411480"/>
           </a:xfrm>
           <a:prstGeom prst="rect">
             <a:avLst/>
@@ -7600,7 +7510,7 @@
                 <a:ea typeface="Arial Black" pitchFamily="34" charset="-122"/>
                 <a:cs typeface="Arial Black" pitchFamily="34" charset="-120"/>
               </a:rPr>
-              <a:t>Готовая. Продающая. Честная.</a:t>
+              <a:t>Готовая, продающая и честная карточка товара</a:t>
             </a:r>
             <a:endParaRPr lang="en-US" sz="1500" dirty="0"/>
           </a:p>
@@ -8580,14 +8490,16 @@
       </p:sp>
       <p:sp>
         <p:nvSpPr>
-          <p:cNvPr id="3" name="Text 1"/>
-          <p:cNvSpPr txBox="1"/>
-          <p:nvPr/>
-        </p:nvSpPr>
-        <p:spPr>
-          <a:xfrm>
-            <a:off x="548640" y="914400"/>
-            <a:ext cx="5852160" cy="5120640"/>
+          <p:cNvPr id="3" name="Text 0"/>
+          <p:cNvSpPr/>
+          <p:nvPr>
+            <p:ph idx="101" type="title" hasCustomPrompt="1"/>
+          </p:nvPr>
+        </p:nvSpPr>
+        <p:spPr>
+          <a:xfrm>
+            <a:off x="548640" y="713232"/>
+            <a:ext cx="11094415" cy="731520"/>
           </a:xfrm>
           <a:prstGeom prst="rect">
             <a:avLst/>
@@ -8599,21 +8511,21 @@
           <a:bodyPr wrap="square" lIns="0" tIns="0" rIns="0" bIns="0" rtlCol="0" anchor="ctr"/>
           <a:lstStyle/>
           <a:p>
-            <a:pPr indent="0" marL="0">
-              <a:buNone/>
-            </a:pPr>
-            <a:r>
-              <a:rPr lang="en-US" sz="4800" dirty="0">
-                <a:solidFill>
-                  <a:schemeClr val="accent1"/>
+            <a:pPr algn="l" indent="0" marL="0">
+              <a:buNone/>
+            </a:pPr>
+            <a:r>
+              <a:rPr lang="en-US" sz="2800" dirty="0">
+                <a:solidFill>
+                  <a:schemeClr val="tx2"/>
                 </a:solidFill>
                 <a:latin typeface="Arial Black" pitchFamily="34" charset="0"/>
                 <a:ea typeface="Arial Black" pitchFamily="34" charset="-122"/>
                 <a:cs typeface="Arial Black" pitchFamily="34" charset="-120"/>
               </a:rPr>
-              <a:t>«Снято честно. Проверено кликом.»</a:t>
-            </a:r>
-            <a:endParaRPr lang="en-US" sz="4800" dirty="0"/>
+              <a:t>Две фразы — два отличия</a:t>
+            </a:r>
+            <a:endParaRPr lang="en-US" sz="2800" dirty="0"/>
           </a:p>
         </p:txBody>
       </p:sp>
@@ -8625,7 +8537,46 @@
         </p:nvSpPr>
         <p:spPr>
           <a:xfrm>
-            <a:off x="6812280" y="1417320"/>
+            <a:off x="548640" y="1600200"/>
+            <a:ext cx="5852160" cy="4663440"/>
+          </a:xfrm>
+          <a:prstGeom prst="rect">
+            <a:avLst/>
+          </a:prstGeom>
+          <a:noFill/>
+          <a:ln/>
+        </p:spPr>
+        <p:txBody>
+          <a:bodyPr wrap="square" lIns="0" tIns="0" rIns="0" bIns="0" rtlCol="0" anchor="ctr"/>
+          <a:lstStyle/>
+          <a:p>
+            <a:pPr indent="0" marL="0">
+              <a:buNone/>
+            </a:pPr>
+            <a:r>
+              <a:rPr lang="en-US" sz="4600" dirty="0">
+                <a:solidFill>
+                  <a:schemeClr val="accent1"/>
+                </a:solidFill>
+                <a:latin typeface="Arial Black" pitchFamily="34" charset="0"/>
+                <a:ea typeface="Arial Black" pitchFamily="34" charset="-122"/>
+                <a:cs typeface="Arial Black" pitchFamily="34" charset="-120"/>
+              </a:rPr>
+              <a:t>«Снято честно. Проверено кликом.»</a:t>
+            </a:r>
+            <a:endParaRPr lang="en-US" sz="4600" dirty="0"/>
+          </a:p>
+        </p:txBody>
+      </p:sp>
+      <p:sp>
+        <p:nvSpPr>
+          <p:cNvPr id="5" name="Text 3"/>
+          <p:cNvSpPr txBox="1"/>
+          <p:nvPr/>
+        </p:nvSpPr>
+        <p:spPr>
+          <a:xfrm>
+            <a:off x="6812280" y="1600200"/>
             <a:ext cx="4830775" cy="274320"/>
           </a:xfrm>
           <a:prstGeom prst="rect">
@@ -8658,13 +8609,13 @@
       </p:sp>
       <p:sp>
         <p:nvSpPr>
-          <p:cNvPr id="5" name="Shape 3"/>
+          <p:cNvPr id="6" name="Shape 4"/>
           <p:cNvSpPr/>
           <p:nvPr/>
         </p:nvSpPr>
         <p:spPr>
           <a:xfrm>
-            <a:off x="6812280" y="1828800"/>
+            <a:off x="6812280" y="2011680"/>
             <a:ext cx="4830775" cy="0"/>
           </a:xfrm>
           <a:prstGeom prst="line">
@@ -8681,13 +8632,13 @@
       </p:sp>
       <p:sp>
         <p:nvSpPr>
-          <p:cNvPr id="6" name="Text 4"/>
+          <p:cNvPr id="7" name="Text 5"/>
           <p:cNvSpPr txBox="1"/>
           <p:nvPr/>
         </p:nvSpPr>
         <p:spPr>
           <a:xfrm>
-            <a:off x="6812280" y="1993392"/>
+            <a:off x="6812280" y="2176272"/>
             <a:ext cx="457200" cy="274320"/>
           </a:xfrm>
           <a:prstGeom prst="rect">
@@ -8720,13 +8671,13 @@
       </p:sp>
       <p:sp>
         <p:nvSpPr>
-          <p:cNvPr id="7" name="Text 5"/>
+          <p:cNvPr id="8" name="Text 6"/>
           <p:cNvSpPr txBox="1"/>
           <p:nvPr/>
         </p:nvSpPr>
         <p:spPr>
           <a:xfrm>
-            <a:off x="7360920" y="1965960"/>
+            <a:off x="7360920" y="2148840"/>
             <a:ext cx="4282135" cy="640080"/>
           </a:xfrm>
           <a:prstGeom prst="rect">
@@ -8751,7 +8702,7 @@
                 <a:ea typeface="Arial" pitchFamily="34" charset="-122"/>
                 <a:cs typeface="Arial" pitchFamily="34" charset="-120"/>
               </a:rPr>
-              <a:t>Две фразы — два наших отличия: реальный товар и обложка, проверенная тестом</a:t>
+              <a:t>«Снято честно» — реальный товар; «проверено кликом» — обложка, прошедшая A/B-тест</a:t>
             </a:r>
             <a:endParaRPr lang="en-US" sz="1500" dirty="0"/>
           </a:p>
@@ -8759,13 +8710,13 @@
       </p:sp>
       <p:sp>
         <p:nvSpPr>
-          <p:cNvPr id="8" name="Shape 6"/>
+          <p:cNvPr id="9" name="Shape 7"/>
           <p:cNvSpPr/>
           <p:nvPr/>
         </p:nvSpPr>
         <p:spPr>
           <a:xfrm>
-            <a:off x="6812280" y="2697480"/>
+            <a:off x="6812280" y="2999232"/>
             <a:ext cx="4830775" cy="0"/>
           </a:xfrm>
           <a:prstGeom prst="line">
@@ -8782,13 +8733,13 @@
       </p:sp>
       <p:sp>
         <p:nvSpPr>
-          <p:cNvPr id="9" name="Text 7"/>
+          <p:cNvPr id="10" name="Text 8"/>
           <p:cNvSpPr txBox="1"/>
           <p:nvPr/>
         </p:nvSpPr>
         <p:spPr>
           <a:xfrm>
-            <a:off x="6812280" y="2862072"/>
+            <a:off x="6812280" y="3163824"/>
             <a:ext cx="457200" cy="274320"/>
           </a:xfrm>
           <a:prstGeom prst="rect">
@@ -8821,13 +8772,13 @@
       </p:sp>
       <p:sp>
         <p:nvSpPr>
-          <p:cNvPr id="10" name="Text 8"/>
+          <p:cNvPr id="11" name="Text 9"/>
           <p:cNvSpPr txBox="1"/>
           <p:nvPr/>
         </p:nvSpPr>
         <p:spPr>
           <a:xfrm>
-            <a:off x="7360920" y="2834640"/>
+            <a:off x="7360920" y="3136392"/>
             <a:ext cx="4282135" cy="640080"/>
           </a:xfrm>
           <a:prstGeom prst="rect">
@@ -8860,13 +8811,13 @@
       </p:sp>
       <p:sp>
         <p:nvSpPr>
-          <p:cNvPr id="11" name="Shape 9"/>
+          <p:cNvPr id="12" name="Shape 10"/>
           <p:cNvSpPr/>
           <p:nvPr/>
         </p:nvSpPr>
         <p:spPr>
           <a:xfrm>
-            <a:off x="6812280" y="3566160"/>
+            <a:off x="6812280" y="3986784"/>
             <a:ext cx="4830775" cy="0"/>
           </a:xfrm>
           <a:prstGeom prst="line">
@@ -8883,13 +8834,13 @@
       </p:sp>
       <p:sp>
         <p:nvSpPr>
-          <p:cNvPr id="12" name="Text 10"/>
+          <p:cNvPr id="13" name="Text 11"/>
           <p:cNvSpPr txBox="1"/>
           <p:nvPr/>
         </p:nvSpPr>
         <p:spPr>
           <a:xfrm>
-            <a:off x="6812280" y="3730752"/>
+            <a:off x="6812280" y="4151376"/>
             <a:ext cx="457200" cy="274320"/>
           </a:xfrm>
           <a:prstGeom prst="rect">
@@ -8922,13 +8873,13 @@
       </p:sp>
       <p:sp>
         <p:nvSpPr>
-          <p:cNvPr id="13" name="Text 11"/>
+          <p:cNvPr id="14" name="Text 12"/>
           <p:cNvSpPr txBox="1"/>
           <p:nvPr/>
         </p:nvSpPr>
         <p:spPr>
           <a:xfrm>
-            <a:off x="7360920" y="3703320"/>
+            <a:off x="7360920" y="4123944"/>
             <a:ext cx="4282135" cy="640080"/>
           </a:xfrm>
           <a:prstGeom prst="rect">
@@ -8961,13 +8912,13 @@
       </p:sp>
       <p:sp>
         <p:nvSpPr>
-          <p:cNvPr id="14" name="tagline"/>
+          <p:cNvPr id="15" name="tagline"/>
           <p:cNvSpPr/>
           <p:nvPr/>
         </p:nvSpPr>
         <p:spPr>
           <a:xfrm>
-            <a:off x="6812280" y="4663440"/>
+            <a:off x="6812280" y="5029200"/>
             <a:ext cx="4830775" cy="1234440"/>
           </a:xfrm>
           <a:prstGeom prst="roundRect">
@@ -8988,13 +8939,13 @@
       </p:sp>
       <p:sp>
         <p:nvSpPr>
-          <p:cNvPr id="15" name="Text 13"/>
+          <p:cNvPr id="16" name="Text 14"/>
           <p:cNvSpPr txBox="1"/>
           <p:nvPr/>
         </p:nvSpPr>
         <p:spPr>
           <a:xfrm>
-            <a:off x="7040880" y="4846320"/>
+            <a:off x="7040880" y="5212080"/>
             <a:ext cx="4373575" cy="228600"/>
           </a:xfrm>
           <a:prstGeom prst="rect">
@@ -9027,13 +8978,13 @@
       </p:sp>
       <p:sp>
         <p:nvSpPr>
-          <p:cNvPr id="16" name="Text 14"/>
+          <p:cNvPr id="17" name="Text 15"/>
           <p:cNvSpPr txBox="1"/>
           <p:nvPr/>
         </p:nvSpPr>
         <p:spPr>
           <a:xfrm>
-            <a:off x="7040880" y="5138928"/>
+            <a:off x="7040880" y="5504688"/>
             <a:ext cx="4373575" cy="640080"/>
           </a:xfrm>
           <a:prstGeom prst="rect">
@@ -9075,36 +9026,6 @@
               <a:t> — описывает весь путь товара. Используем под логотипом и в объявлениях вместе со слоганом.</a:t>
             </a:r>
             <a:endParaRPr lang="en-US" sz="1250" dirty="0"/>
-          </a:p>
-        </p:txBody>
-      </p:sp>
-      <p:sp>
-        <p:nvSpPr>
-          <p:cNvPr id="17" name="Text 0"/>
-          <p:cNvSpPr/>
-          <p:nvPr>
-            <p:ph idx="101" type="title" hasCustomPrompt="1"/>
-          </p:nvPr>
-        </p:nvSpPr>
-        <p:spPr>
-          <a:xfrm>
-            <a:off x="548640" y="713232"/>
-            <a:ext cx="11094415" cy="731520"/>
-          </a:xfrm>
-          <a:prstGeom prst="rect">
-            <a:avLst/>
-          </a:prstGeom>
-          <a:noFill/>
-          <a:ln/>
-        </p:spPr>
-        <p:txBody>
-          <a:bodyPr wrap="square" lIns="0" tIns="0" rIns="0" bIns="0" rtlCol="0" anchor="ctr"/>
-          <a:lstStyle/>
-          <a:p>
-            <a:pPr algn="l" indent="0" marL="0">
-              <a:buNone/>
-            </a:pPr>
-            <a:endParaRPr lang="en-US" sz="2800" dirty="0"/>
           </a:p>
         </p:txBody>
       </p:sp>
@@ -9210,7 +9131,7 @@
                   <a:schemeClr val="accent1"/>
                 </a:solidFill>
               </a:rPr>
-              <a:t>7 · ЛОГОТИП · КОНЦЕПЦИЯ</a:t>
+              <a:t>7 · ЛОГОТИП</a:t>
             </a:r>
             <a:endParaRPr lang="en-US" sz="1100" dirty="0"/>
           </a:p>
@@ -9259,18 +9180,18 @@
       </p:sp>
       <p:sp>
         <p:nvSpPr>
-          <p:cNvPr id="4" name="logo-hero"/>
+          <p:cNvPr id="4" name="logo-main"/>
           <p:cNvSpPr/>
           <p:nvPr/>
         </p:nvSpPr>
         <p:spPr>
           <a:xfrm>
             <a:off x="548640" y="1600200"/>
-            <a:ext cx="5394960" cy="2743200"/>
+            <a:ext cx="6812280" cy="4663440"/>
           </a:xfrm>
           <a:prstGeom prst="roundRect">
             <a:avLst>
-              <a:gd name="adj" fmla="val 2000"/>
+              <a:gd name="adj" fmla="val 1176"/>
             </a:avLst>
           </a:prstGeom>
           <a:solidFill>
@@ -9300,8 +9221,8 @@
         </p:blipFill>
         <p:spPr>
           <a:xfrm>
-            <a:off x="1005840" y="2678582"/>
-            <a:ext cx="4480560" cy="586436"/>
+            <a:off x="1097280" y="3375037"/>
+            <a:ext cx="5715000" cy="748006"/>
           </a:xfrm>
           <a:prstGeom prst="rect">
             <a:avLst/>
@@ -9310,18 +9231,271 @@
       </p:pic>
       <p:sp>
         <p:nvSpPr>
-          <p:cNvPr id="6" name="construction"/>
+          <p:cNvPr id="6" name="Text 3"/>
+          <p:cNvSpPr txBox="1"/>
+          <p:nvPr/>
+        </p:nvSpPr>
+        <p:spPr>
+          <a:xfrm>
+            <a:off x="822960" y="5806440"/>
+            <a:ext cx="3840480" cy="274320"/>
+          </a:xfrm>
+          <a:prstGeom prst="rect">
+            <a:avLst/>
+          </a:prstGeom>
+          <a:noFill/>
+          <a:ln/>
+        </p:spPr>
+        <p:txBody>
+          <a:bodyPr wrap="square" lIns="0" tIns="0" rIns="0" bIns="0" rtlCol="0" anchor="t"/>
+          <a:lstStyle/>
+          <a:p>
+            <a:pPr indent="0" marL="0">
+              <a:buNone/>
+            </a:pPr>
+            <a:r>
+              <a:rPr lang="en-US" sz="1050" dirty="0">
+                <a:solidFill>
+                  <a:schemeClr val="accent3"/>
+                </a:solidFill>
+                <a:latin typeface="Arial" pitchFamily="34" charset="0"/>
+                <a:ea typeface="Arial" pitchFamily="34" charset="-122"/>
+                <a:cs typeface="Arial" pitchFamily="34" charset="-120"/>
+              </a:rPr>
+              <a:t>Ф из шрифта названия в рамке фокуса 4:3</a:t>
+            </a:r>
+            <a:endParaRPr lang="en-US" sz="1050" dirty="0"/>
+          </a:p>
+        </p:txBody>
+      </p:sp>
+      <p:sp>
+        <p:nvSpPr>
+          <p:cNvPr id="7" name="Shape 4"/>
           <p:cNvSpPr/>
           <p:nvPr/>
         </p:nvSpPr>
         <p:spPr>
           <a:xfrm>
-            <a:off x="6172200" y="1600200"/>
-            <a:ext cx="5470855" cy="2743200"/>
+            <a:off x="4983480" y="5843016"/>
+            <a:ext cx="182880" cy="182880"/>
           </a:xfrm>
           <a:prstGeom prst="roundRect">
             <a:avLst>
-              <a:gd name="adj" fmla="val 2000"/>
+              <a:gd name="adj" fmla="val 15000"/>
+            </a:avLst>
+          </a:prstGeom>
+          <a:solidFill>
+            <a:schemeClr val="accent1"/>
+          </a:solidFill>
+          <a:ln/>
+        </p:spPr>
+      </p:sp>
+      <p:sp>
+        <p:nvSpPr>
+          <p:cNvPr id="8" name="Text 5"/>
+          <p:cNvSpPr txBox="1"/>
+          <p:nvPr/>
+        </p:nvSpPr>
+        <p:spPr>
+          <a:xfrm>
+            <a:off x="5230368" y="5806440"/>
+            <a:ext cx="822960" cy="274320"/>
+          </a:xfrm>
+          <a:prstGeom prst="rect">
+            <a:avLst/>
+          </a:prstGeom>
+          <a:noFill/>
+          <a:ln/>
+        </p:spPr>
+        <p:txBody>
+          <a:bodyPr wrap="square" lIns="0" tIns="0" rIns="0" bIns="0" rtlCol="0" anchor="t"/>
+          <a:lstStyle/>
+          <a:p>
+            <a:pPr indent="0" marL="0">
+              <a:buNone/>
+            </a:pPr>
+            <a:r>
+              <a:rPr lang="en-US" sz="1050" dirty="0">
+                <a:solidFill>
+                  <a:schemeClr val="accent3"/>
+                </a:solidFill>
+                <a:latin typeface="Arial" pitchFamily="34" charset="0"/>
+                <a:ea typeface="Arial" pitchFamily="34" charset="-122"/>
+                <a:cs typeface="Arial" pitchFamily="34" charset="-120"/>
+              </a:rPr>
+              <a:t>#7B1E2E</a:t>
+            </a:r>
+            <a:endParaRPr lang="en-US" sz="1050" dirty="0"/>
+          </a:p>
+        </p:txBody>
+      </p:sp>
+      <p:sp>
+        <p:nvSpPr>
+          <p:cNvPr id="9" name="Shape 6"/>
+          <p:cNvSpPr/>
+          <p:nvPr/>
+        </p:nvSpPr>
+        <p:spPr>
+          <a:xfrm>
+            <a:off x="6080760" y="5843016"/>
+            <a:ext cx="182880" cy="182880"/>
+          </a:xfrm>
+          <a:prstGeom prst="roundRect">
+            <a:avLst>
+              <a:gd name="adj" fmla="val 15000"/>
+            </a:avLst>
+          </a:prstGeom>
+          <a:solidFill>
+            <a:schemeClr val="tx2"/>
+          </a:solidFill>
+          <a:ln/>
+        </p:spPr>
+      </p:sp>
+      <p:sp>
+        <p:nvSpPr>
+          <p:cNvPr id="10" name="Text 7"/>
+          <p:cNvSpPr txBox="1"/>
+          <p:nvPr/>
+        </p:nvSpPr>
+        <p:spPr>
+          <a:xfrm>
+            <a:off x="6327648" y="5806440"/>
+            <a:ext cx="822960" cy="274320"/>
+          </a:xfrm>
+          <a:prstGeom prst="rect">
+            <a:avLst/>
+          </a:prstGeom>
+          <a:noFill/>
+          <a:ln/>
+        </p:spPr>
+        <p:txBody>
+          <a:bodyPr wrap="square" lIns="0" tIns="0" rIns="0" bIns="0" rtlCol="0" anchor="t"/>
+          <a:lstStyle/>
+          <a:p>
+            <a:pPr indent="0" marL="0">
+              <a:buNone/>
+            </a:pPr>
+            <a:r>
+              <a:rPr lang="en-US" sz="1050" dirty="0">
+                <a:solidFill>
+                  <a:schemeClr val="accent3"/>
+                </a:solidFill>
+                <a:latin typeface="Arial" pitchFamily="34" charset="0"/>
+                <a:ea typeface="Arial" pitchFamily="34" charset="-122"/>
+                <a:cs typeface="Arial" pitchFamily="34" charset="-120"/>
+              </a:rPr>
+              <a:t>#25272B</a:t>
+            </a:r>
+            <a:endParaRPr lang="en-US" sz="1050" dirty="0"/>
+          </a:p>
+        </p:txBody>
+      </p:sp>
+      <p:sp>
+        <p:nvSpPr>
+          <p:cNvPr id="11" name="logo-lk_dark"/>
+          <p:cNvSpPr/>
+          <p:nvPr/>
+        </p:nvSpPr>
+        <p:spPr>
+          <a:xfrm>
+            <a:off x="7589520" y="1600200"/>
+            <a:ext cx="4053535" cy="1420368"/>
+          </a:xfrm>
+          <a:prstGeom prst="roundRect">
+            <a:avLst>
+              <a:gd name="adj" fmla="val 3863"/>
+            </a:avLst>
+          </a:prstGeom>
+          <a:solidFill>
+            <a:schemeClr val="tx2"/>
+          </a:solidFill>
+          <a:ln/>
+        </p:spPr>
+      </p:sp>
+      <p:pic>
+        <p:nvPicPr>
+          <p:cNvPr id="12" name="Image 1" descr="Логотип на цветном фоне">    </p:cNvPr>
+          <p:cNvPicPr>
+            <a:picLocks noChangeAspect="1"/>
+          </p:cNvPicPr>
+          <p:nvPr/>
+        </p:nvPicPr>
+        <p:blipFill>
+          <a:blip r:embed="rId2"/>
+          <a:stretch>
+            <a:fillRect/>
+          </a:stretch>
+        </p:blipFill>
+        <p:spPr>
+          <a:xfrm>
+            <a:off x="8046720" y="2104952"/>
+            <a:ext cx="3139135" cy="410865"/>
+          </a:xfrm>
+          <a:prstGeom prst="rect">
+            <a:avLst/>
+          </a:prstGeom>
+        </p:spPr>
+      </p:pic>
+      <p:sp>
+        <p:nvSpPr>
+          <p:cNvPr id="13" name="logo-lk_white"/>
+          <p:cNvSpPr/>
+          <p:nvPr/>
+        </p:nvSpPr>
+        <p:spPr>
+          <a:xfrm>
+            <a:off x="7589520" y="3221736"/>
+            <a:ext cx="4053535" cy="1420368"/>
+          </a:xfrm>
+          <a:prstGeom prst="roundRect">
+            <a:avLst>
+              <a:gd name="adj" fmla="val 3863"/>
+            </a:avLst>
+          </a:prstGeom>
+          <a:solidFill>
+            <a:schemeClr val="accent1"/>
+          </a:solidFill>
+          <a:ln/>
+        </p:spPr>
+      </p:sp>
+      <p:pic>
+        <p:nvPicPr>
+          <p:cNvPr id="14" name="Image 2" descr="Логотип на цветном фоне">    </p:cNvPr>
+          <p:cNvPicPr>
+            <a:picLocks noChangeAspect="1"/>
+          </p:cNvPicPr>
+          <p:nvPr/>
+        </p:nvPicPr>
+        <p:blipFill>
+          <a:blip r:embed="rId3"/>
+          <a:stretch>
+            <a:fillRect/>
+          </a:stretch>
+        </p:blipFill>
+        <p:spPr>
+          <a:xfrm>
+            <a:off x="8046720" y="3726488"/>
+            <a:ext cx="3139135" cy="410865"/>
+          </a:xfrm>
+          <a:prstGeom prst="rect">
+            <a:avLst/>
+          </a:prstGeom>
+        </p:spPr>
+      </p:pic>
+      <p:sp>
+        <p:nvSpPr>
+          <p:cNvPr id="15" name="logo-marks"/>
+          <p:cNvSpPr/>
+          <p:nvPr/>
+        </p:nvSpPr>
+        <p:spPr>
+          <a:xfrm>
+            <a:off x="7589520" y="4843272"/>
+            <a:ext cx="4053535" cy="1420368"/>
+          </a:xfrm>
+          <a:prstGeom prst="roundRect">
+            <a:avLst>
+              <a:gd name="adj" fmla="val 3863"/>
             </a:avLst>
           </a:prstGeom>
           <a:solidFill>
@@ -9335,209 +9509,29 @@
           </a:ln>
         </p:spPr>
       </p:sp>
+      <p:sp>
+        <p:nvSpPr>
+          <p:cNvPr id="16" name="Shape 11"/>
+          <p:cNvSpPr/>
+          <p:nvPr/>
+        </p:nvSpPr>
+        <p:spPr>
+          <a:xfrm>
+            <a:off x="7955280" y="5096256"/>
+            <a:ext cx="914400" cy="914400"/>
+          </a:xfrm>
+          <a:prstGeom prst="ellipse">
+            <a:avLst/>
+          </a:prstGeom>
+          <a:solidFill>
+            <a:schemeClr val="tx2"/>
+          </a:solidFill>
+          <a:ln/>
+        </p:spPr>
+      </p:sp>
       <p:pic>
         <p:nvPicPr>
-          <p:cNvPr id="7" name="Image 1" descr="Построение логотипа: высота букв и базовая линия">    </p:cNvPr>
-          <p:cNvPicPr>
-            <a:picLocks noChangeAspect="1"/>
-          </p:cNvPicPr>
-          <p:nvPr/>
-        </p:nvPicPr>
-        <p:blipFill>
-          <a:blip r:embed="rId2"/>
-          <a:stretch>
-            <a:fillRect/>
-          </a:stretch>
-        </p:blipFill>
-        <p:spPr>
-          <a:xfrm>
-            <a:off x="6400800" y="1874520"/>
-            <a:ext cx="5013655" cy="1056734"/>
-          </a:xfrm>
-          <a:prstGeom prst="rect">
-            <a:avLst/>
-          </a:prstGeom>
-        </p:spPr>
-      </p:pic>
-      <p:sp>
-        <p:nvSpPr>
-          <p:cNvPr id="8" name="Text 4"/>
-          <p:cNvSpPr txBox="1"/>
-          <p:nvPr/>
-        </p:nvSpPr>
-        <p:spPr>
-          <a:xfrm>
-            <a:off x="6400800" y="3068414"/>
-            <a:ext cx="5013655" cy="1092106"/>
-          </a:xfrm>
-          <a:prstGeom prst="rect">
-            <a:avLst/>
-          </a:prstGeom>
-          <a:noFill/>
-          <a:ln/>
-        </p:spPr>
-        <p:txBody>
-          <a:bodyPr wrap="square" lIns="0" tIns="0" rIns="0" bIns="0" rtlCol="0" anchor="t"/>
-          <a:lstStyle/>
-          <a:p>
-            <a:pPr indent="0" marL="0">
-              <a:buNone/>
-            </a:pPr>
-            <a:r>
-              <a:rPr lang="en-US" sz="1250" dirty="0">
-                <a:solidFill>
-                  <a:schemeClr val="accent3"/>
-                </a:solidFill>
-                <a:latin typeface="Arial" pitchFamily="34" charset="0"/>
-                <a:ea typeface="Arial" pitchFamily="34" charset="-122"/>
-                <a:cs typeface="Arial" pitchFamily="34" charset="-120"/>
-              </a:rPr>
-              <a:t>Знак — первая буква названия, взятая из того же шрифта. Рамка лишь немного выше букв, поэтому знак не выпадает из слова и логотип читается «ФОТОКОРПУС».</a:t>
-            </a:r>
-            <a:endParaRPr lang="en-US" sz="1250" dirty="0"/>
-          </a:p>
-        </p:txBody>
-      </p:sp>
-      <p:sp>
-        <p:nvSpPr>
-          <p:cNvPr id="9" name="logo-part-1"/>
-          <p:cNvSpPr/>
-          <p:nvPr/>
-        </p:nvSpPr>
-        <p:spPr>
-          <a:xfrm>
-            <a:off x="548640" y="4572000"/>
-            <a:ext cx="3545738" cy="1691640"/>
-          </a:xfrm>
-          <a:prstGeom prst="roundRect">
-            <a:avLst>
-              <a:gd name="adj" fmla="val 3243"/>
-            </a:avLst>
-          </a:prstGeom>
-          <a:solidFill>
-            <a:schemeClr val="bg1"/>
-          </a:solidFill>
-          <a:ln w="9525">
-            <a:solidFill>
-              <a:schemeClr val="accent4"/>
-            </a:solidFill>
-            <a:prstDash val="solid"/>
-          </a:ln>
-        </p:spPr>
-      </p:sp>
-      <p:pic>
-        <p:nvPicPr>
-          <p:cNvPr id="10" name="Image 2" descr="Рамка фокуса">    </p:cNvPr>
-          <p:cNvPicPr>
-            <a:picLocks noChangeAspect="1"/>
-          </p:cNvPicPr>
-          <p:nvPr/>
-        </p:nvPicPr>
-        <p:blipFill>
-          <a:blip r:embed="rId3"/>
-          <a:stretch>
-            <a:fillRect/>
-          </a:stretch>
-        </p:blipFill>
-        <p:spPr>
-          <a:xfrm>
-            <a:off x="777240" y="4846320"/>
-            <a:ext cx="640080" cy="483963"/>
-          </a:xfrm>
-          <a:prstGeom prst="rect">
-            <a:avLst/>
-          </a:prstGeom>
-        </p:spPr>
-      </p:pic>
-      <p:sp>
-        <p:nvSpPr>
-          <p:cNvPr id="11" name="Text 6"/>
-          <p:cNvSpPr txBox="1"/>
-          <p:nvPr/>
-        </p:nvSpPr>
-        <p:spPr>
-          <a:xfrm>
-            <a:off x="1600200" y="4800600"/>
-            <a:ext cx="2311298" cy="1325880"/>
-          </a:xfrm>
-          <a:prstGeom prst="rect">
-            <a:avLst/>
-          </a:prstGeom>
-          <a:noFill/>
-          <a:ln/>
-        </p:spPr>
-        <p:txBody>
-          <a:bodyPr wrap="square" lIns="0" tIns="0" rIns="0" bIns="0" rtlCol="0" anchor="t"/>
-          <a:lstStyle/>
-          <a:p>
-            <a:pPr indent="0" marL="0">
-              <a:spcAft>
-                <a:spcPts val="400"/>
-              </a:spcAft>
-              <a:buNone/>
-            </a:pPr>
-            <a:r>
-              <a:rPr lang="en-US" sz="1350" b="1" dirty="0">
-                <a:solidFill>
-                  <a:schemeClr val="tx1"/>
-                </a:solidFill>
-                <a:latin typeface="Arial" pitchFamily="34" charset="0"/>
-                <a:ea typeface="Arial" pitchFamily="34" charset="-122"/>
-                <a:cs typeface="Arial" pitchFamily="34" charset="-120"/>
-              </a:rPr>
-              <a:t>Рамка фокуса 4:3</a:t>
-            </a:r>
-            <a:endParaRPr lang="en-US" sz="1350" dirty="0"/>
-          </a:p>
-          <a:p>
-            <a:pPr indent="0" marL="0">
-              <a:buNone/>
-            </a:pPr>
-            <a:r>
-              <a:rPr lang="en-US" sz="1150" dirty="0">
-                <a:solidFill>
-                  <a:schemeClr val="accent3"/>
-                </a:solidFill>
-                <a:latin typeface="Arial" pitchFamily="34" charset="0"/>
-                <a:ea typeface="Arial" pitchFamily="34" charset="-122"/>
-                <a:cs typeface="Arial" pitchFamily="34" charset="-120"/>
-              </a:rPr>
-              <a:t>Так камера показывает, что в фокусе: реальный товар. Кадр 4:3, повёрнутый на 90°, — формат карточки 3:4.</a:t>
-            </a:r>
-            <a:endParaRPr lang="en-US" sz="1350" dirty="0"/>
-          </a:p>
-        </p:txBody>
-      </p:sp>
-      <p:sp>
-        <p:nvSpPr>
-          <p:cNvPr id="12" name="logo-part-2"/>
-          <p:cNvSpPr/>
-          <p:nvPr/>
-        </p:nvSpPr>
-        <p:spPr>
-          <a:xfrm>
-            <a:off x="4322978" y="4572000"/>
-            <a:ext cx="3545738" cy="1691640"/>
-          </a:xfrm>
-          <a:prstGeom prst="roundRect">
-            <a:avLst>
-              <a:gd name="adj" fmla="val 3243"/>
-            </a:avLst>
-          </a:prstGeom>
-          <a:solidFill>
-            <a:schemeClr val="bg1"/>
-          </a:solidFill>
-          <a:ln w="9525">
-            <a:solidFill>
-              <a:schemeClr val="accent4"/>
-            </a:solidFill>
-            <a:prstDash val="solid"/>
-          </a:ln>
-        </p:spPr>
-      </p:sp>
-      <p:pic>
-        <p:nvPicPr>
-          <p:cNvPr id="13" name="Image 3" descr="Буква Ф">    </p:cNvPr>
+          <p:cNvPr id="17" name="Image 3" descr="Аватар">    </p:cNvPr>
           <p:cNvPicPr>
             <a:picLocks noChangeAspect="1"/>
           </p:cNvPicPr>
@@ -9551,24 +9545,48 @@
         </p:blipFill>
         <p:spPr>
           <a:xfrm>
-            <a:off x="4615586" y="4818888"/>
-            <a:ext cx="512064" cy="409531"/>
+            <a:off x="8129016" y="5338912"/>
+            <a:ext cx="566928" cy="429089"/>
           </a:xfrm>
           <a:prstGeom prst="rect">
             <a:avLst/>
           </a:prstGeom>
         </p:spPr>
       </p:pic>
-      <p:sp>
-        <p:nvSpPr>
-          <p:cNvPr id="14" name="Text 8"/>
+      <p:pic>
+        <p:nvPicPr>
+          <p:cNvPr id="18" name="Image 4" descr="Знак 64">    </p:cNvPr>
+          <p:cNvPicPr>
+            <a:picLocks noChangeAspect="1"/>
+          </p:cNvPicPr>
+          <p:nvPr/>
+        </p:nvPicPr>
+        <p:blipFill>
+          <a:blip r:embed="rId5"/>
+          <a:stretch>
+            <a:fillRect/>
+          </a:stretch>
+        </p:blipFill>
+        <p:spPr>
+          <a:xfrm>
+            <a:off x="9281160" y="5228393"/>
+            <a:ext cx="731520" cy="553663"/>
+          </a:xfrm>
+          <a:prstGeom prst="rect">
+            <a:avLst/>
+          </a:prstGeom>
+        </p:spPr>
+      </p:pic>
+      <p:sp>
+        <p:nvSpPr>
+          <p:cNvPr id="19" name="Text 12"/>
           <p:cNvSpPr txBox="1"/>
           <p:nvPr/>
         </p:nvSpPr>
         <p:spPr>
           <a:xfrm>
-            <a:off x="5374538" y="4800600"/>
-            <a:ext cx="2311298" cy="1325880"/>
+            <a:off x="9144000" y="5836920"/>
+            <a:ext cx="1005840" cy="201168"/>
           </a:xfrm>
           <a:prstGeom prst="rect">
             <a:avLst/>
@@ -9580,31 +9598,74 @@
           <a:bodyPr wrap="square" lIns="0" tIns="0" rIns="0" bIns="0" rtlCol="0" anchor="t"/>
           <a:lstStyle/>
           <a:p>
-            <a:pPr indent="0" marL="0">
-              <a:spcAft>
-                <a:spcPts val="400"/>
-              </a:spcAft>
-              <a:buNone/>
-            </a:pPr>
-            <a:r>
-              <a:rPr lang="en-US" sz="1350" b="1" dirty="0">
-                <a:solidFill>
-                  <a:schemeClr val="tx1"/>
+            <a:pPr algn="ctr" indent="0" marL="0">
+              <a:buNone/>
+            </a:pPr>
+            <a:r>
+              <a:rPr lang="en-US" sz="950" dirty="0">
+                <a:solidFill>
+                  <a:schemeClr val="accent3"/>
                 </a:solidFill>
                 <a:latin typeface="Arial" pitchFamily="34" charset="0"/>
                 <a:ea typeface="Arial" pitchFamily="34" charset="-122"/>
                 <a:cs typeface="Arial" pitchFamily="34" charset="-120"/>
               </a:rPr>
-              <a:t>Ф из шрифта названия</a:t>
-            </a:r>
-            <a:endParaRPr lang="en-US" sz="1350" dirty="0"/>
-          </a:p>
-          <a:p>
-            <a:pPr indent="0" marL="0">
-              <a:buNone/>
-            </a:pPr>
-            <a:r>
-              <a:rPr lang="en-US" sz="1150" dirty="0">
+              <a:t>64</a:t>
+            </a:r>
+            <a:endParaRPr lang="en-US" sz="950" dirty="0"/>
+          </a:p>
+        </p:txBody>
+      </p:sp>
+      <p:pic>
+        <p:nvPicPr>
+          <p:cNvPr id="20" name="Image 5" descr="Знак 32">    </p:cNvPr>
+          <p:cNvPicPr>
+            <a:picLocks noChangeAspect="1"/>
+          </p:cNvPicPr>
+          <p:nvPr/>
+        </p:nvPicPr>
+        <p:blipFill>
+          <a:blip r:embed="rId6"/>
+          <a:stretch>
+            <a:fillRect/>
+          </a:stretch>
+        </p:blipFill>
+        <p:spPr>
+          <a:xfrm>
+            <a:off x="10287000" y="5505225"/>
+            <a:ext cx="365760" cy="276831"/>
+          </a:xfrm>
+          <a:prstGeom prst="rect">
+            <a:avLst/>
+          </a:prstGeom>
+        </p:spPr>
+      </p:pic>
+      <p:sp>
+        <p:nvSpPr>
+          <p:cNvPr id="21" name="Text 13"/>
+          <p:cNvSpPr txBox="1"/>
+          <p:nvPr/>
+        </p:nvSpPr>
+        <p:spPr>
+          <a:xfrm>
+            <a:off x="10149840" y="5836920"/>
+            <a:ext cx="640080" cy="201168"/>
+          </a:xfrm>
+          <a:prstGeom prst="rect">
+            <a:avLst/>
+          </a:prstGeom>
+          <a:noFill/>
+          <a:ln/>
+        </p:spPr>
+        <p:txBody>
+          <a:bodyPr wrap="square" lIns="0" tIns="0" rIns="0" bIns="0" rtlCol="0" anchor="t"/>
+          <a:lstStyle/>
+          <a:p>
+            <a:pPr algn="ctr" indent="0" marL="0">
+              <a:buNone/>
+            </a:pPr>
+            <a:r>
+              <a:rPr lang="en-US" sz="950" dirty="0">
                 <a:solidFill>
                   <a:schemeClr val="accent3"/>
                 </a:solidFill>
@@ -9612,93 +9673,46 @@
                 <a:ea typeface="Arial" pitchFamily="34" charset="-122"/>
                 <a:cs typeface="Arial" pitchFamily="34" charset="-120"/>
               </a:rPr>
-              <a:t>Та же буква, что в слове: знак работает и внутри логотипа, и отдельно на аватаре.</a:t>
-            </a:r>
-            <a:endParaRPr lang="en-US" sz="1350" dirty="0"/>
-          </a:p>
-        </p:txBody>
-      </p:sp>
-      <p:sp>
-        <p:nvSpPr>
-          <p:cNvPr id="15" name="logo-part-3"/>
-          <p:cNvSpPr/>
-          <p:nvPr/>
-        </p:nvSpPr>
-        <p:spPr>
-          <a:xfrm>
-            <a:off x="8097317" y="4572000"/>
-            <a:ext cx="3545738" cy="1691640"/>
-          </a:xfrm>
-          <a:prstGeom prst="roundRect">
-            <a:avLst>
-              <a:gd name="adj" fmla="val 3243"/>
-            </a:avLst>
-          </a:prstGeom>
-          <a:solidFill>
-            <a:schemeClr val="bg1"/>
-          </a:solidFill>
-          <a:ln w="9525">
-            <a:solidFill>
-              <a:schemeClr val="accent4"/>
-            </a:solidFill>
-            <a:prstDash val="solid"/>
-          </a:ln>
-        </p:spPr>
-      </p:sp>
-      <p:sp>
-        <p:nvSpPr>
-          <p:cNvPr id="16" name="Shape 10"/>
-          <p:cNvSpPr/>
-          <p:nvPr/>
-        </p:nvSpPr>
-        <p:spPr>
-          <a:xfrm>
-            <a:off x="8325917" y="4873752"/>
-            <a:ext cx="292608" cy="292608"/>
-          </a:xfrm>
-          <a:prstGeom prst="roundRect">
-            <a:avLst>
-              <a:gd name="adj" fmla="val 15625"/>
-            </a:avLst>
-          </a:prstGeom>
-          <a:solidFill>
-            <a:schemeClr val="tx2"/>
-          </a:solidFill>
-          <a:ln/>
-        </p:spPr>
-      </p:sp>
-      <p:sp>
-        <p:nvSpPr>
-          <p:cNvPr id="17" name="Shape 11"/>
-          <p:cNvSpPr/>
-          <p:nvPr/>
-        </p:nvSpPr>
-        <p:spPr>
-          <a:xfrm>
-            <a:off x="8664245" y="4873752"/>
-            <a:ext cx="292608" cy="292608"/>
-          </a:xfrm>
-          <a:prstGeom prst="roundRect">
-            <a:avLst>
-              <a:gd name="adj" fmla="val 15625"/>
-            </a:avLst>
-          </a:prstGeom>
-          <a:solidFill>
-            <a:schemeClr val="accent1"/>
-          </a:solidFill>
-          <a:ln/>
-        </p:spPr>
-      </p:sp>
-      <p:sp>
-        <p:nvSpPr>
-          <p:cNvPr id="18" name="Text 12"/>
+              <a:t>32</a:t>
+            </a:r>
+            <a:endParaRPr lang="en-US" sz="950" dirty="0"/>
+          </a:p>
+        </p:txBody>
+      </p:sp>
+      <p:pic>
+        <p:nvPicPr>
+          <p:cNvPr id="22" name="Image 6" descr="Знак 16 px">    </p:cNvPr>
+          <p:cNvPicPr>
+            <a:picLocks noChangeAspect="1"/>
+          </p:cNvPicPr>
+          <p:nvPr/>
+        </p:nvPicPr>
+        <p:blipFill>
+          <a:blip r:embed="rId7"/>
+          <a:stretch>
+            <a:fillRect/>
+          </a:stretch>
+        </p:blipFill>
+        <p:spPr>
+          <a:xfrm>
+            <a:off x="10927080" y="5629799"/>
+            <a:ext cx="201168" cy="152257"/>
+          </a:xfrm>
+          <a:prstGeom prst="rect">
+            <a:avLst/>
+          </a:prstGeom>
+        </p:spPr>
+      </p:pic>
+      <p:sp>
+        <p:nvSpPr>
+          <p:cNvPr id="23" name="Text 14"/>
           <p:cNvSpPr txBox="1"/>
           <p:nvPr/>
         </p:nvSpPr>
         <p:spPr>
           <a:xfrm>
-            <a:off x="9148877" y="4800600"/>
-            <a:ext cx="2311298" cy="1325880"/>
+            <a:off x="10789920" y="5836920"/>
+            <a:ext cx="475488" cy="201168"/>
           </a:xfrm>
           <a:prstGeom prst="rect">
             <a:avLst/>
@@ -9710,41 +9724,21 @@
           <a:bodyPr wrap="square" lIns="0" tIns="0" rIns="0" bIns="0" rtlCol="0" anchor="t"/>
           <a:lstStyle/>
           <a:p>
-            <a:pPr indent="0" marL="0">
-              <a:spcAft>
-                <a:spcPts val="400"/>
-              </a:spcAft>
-              <a:buNone/>
-            </a:pPr>
-            <a:r>
-              <a:rPr lang="en-US" sz="1350" b="1" dirty="0">
-                <a:solidFill>
-                  <a:schemeClr val="tx1"/>
+            <a:pPr algn="ctr" indent="0" marL="0">
+              <a:buNone/>
+            </a:pPr>
+            <a:r>
+              <a:rPr lang="en-US" sz="950" dirty="0">
+                <a:solidFill>
+                  <a:schemeClr val="accent3"/>
                 </a:solidFill>
                 <a:latin typeface="Arial" pitchFamily="34" charset="0"/>
                 <a:ea typeface="Arial" pitchFamily="34" charset="-122"/>
                 <a:cs typeface="Arial" pitchFamily="34" charset="-120"/>
               </a:rPr>
-              <a:t>Два цвета</a:t>
-            </a:r>
-            <a:endParaRPr lang="en-US" sz="1350" dirty="0"/>
-          </a:p>
-          <a:p>
-            <a:pPr indent="0" marL="0">
-              <a:buNone/>
-            </a:pPr>
-            <a:r>
-              <a:rPr lang="en-US" sz="1150" dirty="0">
-                <a:solidFill>
-                  <a:schemeClr val="accent3"/>
-                </a:solidFill>
-                <a:latin typeface="Arial" pitchFamily="34" charset="0"/>
-                <a:ea typeface="Arial" pitchFamily="34" charset="-122"/>
-                <a:cs typeface="Arial" pitchFamily="34" charset="-120"/>
-              </a:rPr>
-              <a:t>ФОТО графитом, КОРПУС и рамка бордо: видно, из каких двух слов состоит название.</a:t>
-            </a:r>
-            <a:endParaRPr lang="en-US" sz="1350" dirty="0"/>
+              <a:t>16 px</a:t>
+            </a:r>
+            <a:endParaRPr lang="en-US" sz="950" dirty="0"/>
           </a:p>
         </p:txBody>
       </p:sp>
@@ -9788,1173 +9782,6 @@
             <a:fld id="{F7021451-1387-4CA6-816F-3879F97B5CBC}" type="slidenum">
               <a:rPr b="0" lang="en-US"/>
               <a:t>8</a:t>
-            </a:fld>
-            <a:endParaRPr lang="en-US"/>
-          </a:p>
-        </p:txBody>
-      </p:sp>
-    </p:spTree>
-  </p:cSld>
-  <p:clrMapOvr>
-    <a:masterClrMapping/>
-  </p:clrMapOvr>
-</p:sld>
-</file>
-
-<file path=ppt/slides/slide9.xml><?xml version="1.0" encoding="utf-8"?>
-<p:sld xmlns:a="http://schemas.openxmlformats.org/drawingml/2006/main" xmlns:r="http://schemas.openxmlformats.org/officeDocument/2006/relationships" xmlns:p="http://schemas.openxmlformats.org/presentationml/2006/main">
-  <p:cSld name="Slide 9">
-    <p:spTree>
-      <p:nvGrpSpPr>
-        <p:cNvPr id="1" name=""/>
-        <p:cNvGrpSpPr/>
-        <p:nvPr/>
-      </p:nvGrpSpPr>
-      <p:grpSpPr>
-        <a:xfrm>
-          <a:off x="0" y="0"/>
-          <a:ext cx="0" cy="0"/>
-          <a:chOff x="0" y="0"/>
-          <a:chExt cx="0" cy="0"/>
-        </a:xfrm>
-      </p:grpSpPr>
-      <p:sp>
-        <p:nvSpPr>
-          <p:cNvPr id="2" name="Text 0"/>
-          <p:cNvSpPr/>
-          <p:nvPr>
-            <p:ph idx="100" type="body" hasCustomPrompt="1"/>
-          </p:nvPr>
-        </p:nvSpPr>
-        <p:spPr>
-          <a:xfrm>
-            <a:off x="548640" y="384048"/>
-            <a:ext cx="11094415" cy="292608"/>
-          </a:xfrm>
-          <a:prstGeom prst="rect">
-            <a:avLst/>
-          </a:prstGeom>
-          <a:noFill/>
-          <a:ln/>
-        </p:spPr>
-        <p:txBody>
-          <a:bodyPr wrap="square" lIns="0" tIns="0" rIns="0" bIns="0" rtlCol="0" anchor="ctr"/>
-          <a:lstStyle/>
-          <a:p>
-            <a:pPr indent="0" marL="0">
-              <a:buNone/>
-            </a:pPr>
-            <a:r>
-              <a:rPr lang="en-US" sz="1100" b="1" spc="200" kern="0" dirty="0">
-                <a:solidFill>
-                  <a:schemeClr val="accent1"/>
-                </a:solidFill>
-              </a:rPr>
-              <a:t>7 · ЛОГОТИП · ВЕРСИИ</a:t>
-            </a:r>
-            <a:endParaRPr lang="en-US" sz="1100" dirty="0"/>
-          </a:p>
-        </p:txBody>
-      </p:sp>
-      <p:sp>
-        <p:nvSpPr>
-          <p:cNvPr id="3" name="Text 0"/>
-          <p:cNvSpPr/>
-          <p:nvPr>
-            <p:ph idx="101" type="title" hasCustomPrompt="1"/>
-          </p:nvPr>
-        </p:nvSpPr>
-        <p:spPr>
-          <a:xfrm>
-            <a:off x="548640" y="713232"/>
-            <a:ext cx="11094415" cy="731520"/>
-          </a:xfrm>
-          <a:prstGeom prst="rect">
-            <a:avLst/>
-          </a:prstGeom>
-          <a:noFill/>
-          <a:ln/>
-        </p:spPr>
-        <p:txBody>
-          <a:bodyPr wrap="square" lIns="0" tIns="0" rIns="0" bIns="0" rtlCol="0" anchor="ctr"/>
-          <a:lstStyle/>
-          <a:p>
-            <a:pPr algn="l" indent="0" marL="0">
-              <a:buNone/>
-            </a:pPr>
-            <a:r>
-              <a:rPr lang="en-US" sz="2800" dirty="0">
-                <a:solidFill>
-                  <a:schemeClr val="tx2"/>
-                </a:solidFill>
-                <a:latin typeface="Arial Black" pitchFamily="34" charset="0"/>
-                <a:ea typeface="Arial Black" pitchFamily="34" charset="-122"/>
-                <a:cs typeface="Arial Black" pitchFamily="34" charset="-120"/>
-              </a:rPr>
-              <a:t>Как логотип живёт в носителях</a:t>
-            </a:r>
-            <a:endParaRPr lang="en-US" sz="2800" dirty="0"/>
-          </a:p>
-        </p:txBody>
-      </p:sp>
-      <p:sp>
-        <p:nvSpPr>
-          <p:cNvPr id="4" name="logo-tile-1"/>
-          <p:cNvSpPr/>
-          <p:nvPr/>
-        </p:nvSpPr>
-        <p:spPr>
-          <a:xfrm>
-            <a:off x="548640" y="1600200"/>
-            <a:ext cx="3545738" cy="2011680"/>
-          </a:xfrm>
-          <a:prstGeom prst="roundRect">
-            <a:avLst>
-              <a:gd name="adj" fmla="val 2727"/>
-            </a:avLst>
-          </a:prstGeom>
-          <a:solidFill>
-            <a:schemeClr val="bg1"/>
-          </a:solidFill>
-          <a:ln w="9525">
-            <a:solidFill>
-              <a:schemeClr val="accent4"/>
-            </a:solidFill>
-            <a:prstDash val="solid"/>
-          </a:ln>
-        </p:spPr>
-      </p:sp>
-      <p:pic>
-        <p:nvPicPr>
-          <p:cNvPr id="5" name="Image 0" descr="Логотип: Основной, светлый фон">    </p:cNvPr>
-          <p:cNvPicPr>
-            <a:picLocks noChangeAspect="1"/>
-          </p:cNvPicPr>
-          <p:nvPr/>
-        </p:nvPicPr>
-        <p:blipFill>
-          <a:blip r:embed="rId1"/>
-          <a:stretch>
-            <a:fillRect/>
-          </a:stretch>
-        </p:blipFill>
-        <p:spPr>
-          <a:xfrm>
-            <a:off x="914400" y="2421871"/>
-            <a:ext cx="2814218" cy="368338"/>
-          </a:xfrm>
-          <a:prstGeom prst="rect">
-            <a:avLst/>
-          </a:prstGeom>
-        </p:spPr>
-      </p:pic>
-      <p:sp>
-        <p:nvSpPr>
-          <p:cNvPr id="6" name="Text 3"/>
-          <p:cNvSpPr txBox="1"/>
-          <p:nvPr/>
-        </p:nvSpPr>
-        <p:spPr>
-          <a:xfrm>
-            <a:off x="548640" y="3703320"/>
-            <a:ext cx="3545738" cy="228600"/>
-          </a:xfrm>
-          <a:prstGeom prst="rect">
-            <a:avLst/>
-          </a:prstGeom>
-          <a:noFill/>
-          <a:ln/>
-        </p:spPr>
-        <p:txBody>
-          <a:bodyPr wrap="square" lIns="0" tIns="0" rIns="0" bIns="0" rtlCol="0" anchor="t"/>
-          <a:lstStyle/>
-          <a:p>
-            <a:pPr indent="0" marL="0">
-              <a:buNone/>
-            </a:pPr>
-            <a:r>
-              <a:rPr lang="en-US" sz="950" b="1" spc="150" kern="0" dirty="0">
-                <a:solidFill>
-                  <a:schemeClr val="accent3"/>
-                </a:solidFill>
-                <a:latin typeface="Arial" pitchFamily="34" charset="0"/>
-                <a:ea typeface="Arial" pitchFamily="34" charset="-122"/>
-                <a:cs typeface="Arial" pitchFamily="34" charset="-120"/>
-              </a:rPr>
-              <a:t>ОСНОВНОЙ, СВЕТЛЫЙ ФОН</a:t>
-            </a:r>
-            <a:endParaRPr lang="en-US" sz="950" dirty="0"/>
-          </a:p>
-        </p:txBody>
-      </p:sp>
-      <p:sp>
-        <p:nvSpPr>
-          <p:cNvPr id="7" name="logo-tile-2"/>
-          <p:cNvSpPr/>
-          <p:nvPr/>
-        </p:nvSpPr>
-        <p:spPr>
-          <a:xfrm>
-            <a:off x="4322978" y="1600200"/>
-            <a:ext cx="3545738" cy="2011680"/>
-          </a:xfrm>
-          <a:prstGeom prst="roundRect">
-            <a:avLst>
-              <a:gd name="adj" fmla="val 2727"/>
-            </a:avLst>
-          </a:prstGeom>
-          <a:solidFill>
-            <a:schemeClr val="tx2"/>
-          </a:solidFill>
-          <a:ln/>
-        </p:spPr>
-      </p:sp>
-      <p:pic>
-        <p:nvPicPr>
-          <p:cNvPr id="8" name="Image 1" descr="Логотип: Графитовый фон">    </p:cNvPr>
-          <p:cNvPicPr>
-            <a:picLocks noChangeAspect="1"/>
-          </p:cNvPicPr>
-          <p:nvPr/>
-        </p:nvPicPr>
-        <p:blipFill>
-          <a:blip r:embed="rId2"/>
-          <a:stretch>
-            <a:fillRect/>
-          </a:stretch>
-        </p:blipFill>
-        <p:spPr>
-          <a:xfrm>
-            <a:off x="4688738" y="2421871"/>
-            <a:ext cx="2814218" cy="368338"/>
-          </a:xfrm>
-          <a:prstGeom prst="rect">
-            <a:avLst/>
-          </a:prstGeom>
-        </p:spPr>
-      </p:pic>
-      <p:sp>
-        <p:nvSpPr>
-          <p:cNvPr id="9" name="Text 5"/>
-          <p:cNvSpPr txBox="1"/>
-          <p:nvPr/>
-        </p:nvSpPr>
-        <p:spPr>
-          <a:xfrm>
-            <a:off x="4322978" y="3703320"/>
-            <a:ext cx="3545738" cy="228600"/>
-          </a:xfrm>
-          <a:prstGeom prst="rect">
-            <a:avLst/>
-          </a:prstGeom>
-          <a:noFill/>
-          <a:ln/>
-        </p:spPr>
-        <p:txBody>
-          <a:bodyPr wrap="square" lIns="0" tIns="0" rIns="0" bIns="0" rtlCol="0" anchor="t"/>
-          <a:lstStyle/>
-          <a:p>
-            <a:pPr indent="0" marL="0">
-              <a:buNone/>
-            </a:pPr>
-            <a:r>
-              <a:rPr lang="en-US" sz="950" b="1" spc="150" kern="0" dirty="0">
-                <a:solidFill>
-                  <a:schemeClr val="accent3"/>
-                </a:solidFill>
-                <a:latin typeface="Arial" pitchFamily="34" charset="0"/>
-                <a:ea typeface="Arial" pitchFamily="34" charset="-122"/>
-                <a:cs typeface="Arial" pitchFamily="34" charset="-120"/>
-              </a:rPr>
-              <a:t>ГРАФИТОВЫЙ ФОН</a:t>
-            </a:r>
-            <a:endParaRPr lang="en-US" sz="950" dirty="0"/>
-          </a:p>
-        </p:txBody>
-      </p:sp>
-      <p:sp>
-        <p:nvSpPr>
-          <p:cNvPr id="10" name="logo-tile-3"/>
-          <p:cNvSpPr/>
-          <p:nvPr/>
-        </p:nvSpPr>
-        <p:spPr>
-          <a:xfrm>
-            <a:off x="8097317" y="1600200"/>
-            <a:ext cx="3545738" cy="2011680"/>
-          </a:xfrm>
-          <a:prstGeom prst="roundRect">
-            <a:avLst>
-              <a:gd name="adj" fmla="val 2727"/>
-            </a:avLst>
-          </a:prstGeom>
-          <a:solidFill>
-            <a:schemeClr val="accent1"/>
-          </a:solidFill>
-          <a:ln/>
-        </p:spPr>
-      </p:sp>
-      <p:pic>
-        <p:nvPicPr>
-          <p:cNvPr id="11" name="Image 2" descr="Логотип: Бордо, одноцветный">    </p:cNvPr>
-          <p:cNvPicPr>
-            <a:picLocks noChangeAspect="1"/>
-          </p:cNvPicPr>
-          <p:nvPr/>
-        </p:nvPicPr>
-        <p:blipFill>
-          <a:blip r:embed="rId3"/>
-          <a:stretch>
-            <a:fillRect/>
-          </a:stretch>
-        </p:blipFill>
-        <p:spPr>
-          <a:xfrm>
-            <a:off x="8463077" y="2421871"/>
-            <a:ext cx="2814218" cy="368338"/>
-          </a:xfrm>
-          <a:prstGeom prst="rect">
-            <a:avLst/>
-          </a:prstGeom>
-        </p:spPr>
-      </p:pic>
-      <p:sp>
-        <p:nvSpPr>
-          <p:cNvPr id="12" name="Text 7"/>
-          <p:cNvSpPr txBox="1"/>
-          <p:nvPr/>
-        </p:nvSpPr>
-        <p:spPr>
-          <a:xfrm>
-            <a:off x="8097317" y="3703320"/>
-            <a:ext cx="3545738" cy="228600"/>
-          </a:xfrm>
-          <a:prstGeom prst="rect">
-            <a:avLst/>
-          </a:prstGeom>
-          <a:noFill/>
-          <a:ln/>
-        </p:spPr>
-        <p:txBody>
-          <a:bodyPr wrap="square" lIns="0" tIns="0" rIns="0" bIns="0" rtlCol="0" anchor="t"/>
-          <a:lstStyle/>
-          <a:p>
-            <a:pPr indent="0" marL="0">
-              <a:buNone/>
-            </a:pPr>
-            <a:r>
-              <a:rPr lang="en-US" sz="950" b="1" spc="150" kern="0" dirty="0">
-                <a:solidFill>
-                  <a:schemeClr val="accent3"/>
-                </a:solidFill>
-                <a:latin typeface="Arial" pitchFamily="34" charset="0"/>
-                <a:ea typeface="Arial" pitchFamily="34" charset="-122"/>
-                <a:cs typeface="Arial" pitchFamily="34" charset="-120"/>
-              </a:rPr>
-              <a:t>БОРДО, ОДНОЦВЕТНЫЙ</a:t>
-            </a:r>
-            <a:endParaRPr lang="en-US" sz="950" dirty="0"/>
-          </a:p>
-        </p:txBody>
-      </p:sp>
-      <p:sp>
-        <p:nvSpPr>
-          <p:cNvPr id="13" name="logo-vertical"/>
-          <p:cNvSpPr/>
-          <p:nvPr/>
-        </p:nvSpPr>
-        <p:spPr>
-          <a:xfrm>
-            <a:off x="548640" y="4069080"/>
-            <a:ext cx="2602154" cy="1874520"/>
-          </a:xfrm>
-          <a:prstGeom prst="roundRect">
-            <a:avLst>
-              <a:gd name="adj" fmla="val 2927"/>
-            </a:avLst>
-          </a:prstGeom>
-          <a:solidFill>
-            <a:schemeClr val="bg1"/>
-          </a:solidFill>
-          <a:ln w="9525">
-            <a:solidFill>
-              <a:schemeClr val="accent4"/>
-            </a:solidFill>
-            <a:prstDash val="solid"/>
-          </a:ln>
-        </p:spPr>
-      </p:sp>
-      <p:pic>
-        <p:nvPicPr>
-          <p:cNvPr id="14" name="Image 3" descr="Вертикальный логотип">    </p:cNvPr>
-          <p:cNvPicPr>
-            <a:picLocks noChangeAspect="1"/>
-          </p:cNvPicPr>
-          <p:nvPr/>
-        </p:nvPicPr>
-        <p:blipFill>
-          <a:blip r:embed="rId4"/>
-          <a:stretch>
-            <a:fillRect/>
-          </a:stretch>
-        </p:blipFill>
-        <p:spPr>
-          <a:xfrm>
-            <a:off x="1005840" y="4529090"/>
-            <a:ext cx="1687754" cy="954499"/>
-          </a:xfrm>
-          <a:prstGeom prst="rect">
-            <a:avLst/>
-          </a:prstGeom>
-        </p:spPr>
-      </p:pic>
-      <p:sp>
-        <p:nvSpPr>
-          <p:cNvPr id="15" name="Text 9"/>
-          <p:cNvSpPr txBox="1"/>
-          <p:nvPr/>
-        </p:nvSpPr>
-        <p:spPr>
-          <a:xfrm>
-            <a:off x="548640" y="6035040"/>
-            <a:ext cx="2602154" cy="228600"/>
-          </a:xfrm>
-          <a:prstGeom prst="rect">
-            <a:avLst/>
-          </a:prstGeom>
-          <a:noFill/>
-          <a:ln/>
-        </p:spPr>
-        <p:txBody>
-          <a:bodyPr wrap="square" lIns="0" tIns="0" rIns="0" bIns="0" rtlCol="0" anchor="t"/>
-          <a:lstStyle/>
-          <a:p>
-            <a:pPr indent="0" marL="0">
-              <a:buNone/>
-            </a:pPr>
-            <a:r>
-              <a:rPr lang="en-US" sz="950" b="1" spc="150" kern="0" dirty="0">
-                <a:solidFill>
-                  <a:schemeClr val="accent3"/>
-                </a:solidFill>
-                <a:latin typeface="Arial" pitchFamily="34" charset="0"/>
-                <a:ea typeface="Arial" pitchFamily="34" charset="-122"/>
-                <a:cs typeface="Arial" pitchFamily="34" charset="-120"/>
-              </a:rPr>
-              <a:t>ВЕРТИКАЛЬНЫЙ</a:t>
-            </a:r>
-            <a:endParaRPr lang="en-US" sz="950" dirty="0"/>
-          </a:p>
-        </p:txBody>
-      </p:sp>
-      <p:sp>
-        <p:nvSpPr>
-          <p:cNvPr id="16" name="logo-avatar"/>
-          <p:cNvSpPr/>
-          <p:nvPr/>
-        </p:nvSpPr>
-        <p:spPr>
-          <a:xfrm>
-            <a:off x="3379394" y="4069080"/>
-            <a:ext cx="2602154" cy="1874520"/>
-          </a:xfrm>
-          <a:prstGeom prst="roundRect">
-            <a:avLst>
-              <a:gd name="adj" fmla="val 2927"/>
-            </a:avLst>
-          </a:prstGeom>
-          <a:solidFill>
-            <a:schemeClr val="bg1"/>
-          </a:solidFill>
-          <a:ln w="9525">
-            <a:solidFill>
-              <a:schemeClr val="accent4"/>
-            </a:solidFill>
-            <a:prstDash val="solid"/>
-          </a:ln>
-        </p:spPr>
-      </p:sp>
-      <p:sp>
-        <p:nvSpPr>
-          <p:cNvPr id="17" name="Shape 11"/>
-          <p:cNvSpPr/>
-          <p:nvPr/>
-        </p:nvSpPr>
-        <p:spPr>
-          <a:xfrm>
-            <a:off x="4108971" y="4434840"/>
-            <a:ext cx="1143000" cy="1143000"/>
-          </a:xfrm>
-          <a:prstGeom prst="ellipse">
-            <a:avLst/>
-          </a:prstGeom>
-          <a:solidFill>
-            <a:schemeClr val="tx2"/>
-          </a:solidFill>
-          <a:ln/>
-        </p:spPr>
-      </p:sp>
-      <p:pic>
-        <p:nvPicPr>
-          <p:cNvPr id="18" name="Image 4" descr="Аватар">    </p:cNvPr>
-          <p:cNvPicPr>
-            <a:picLocks noChangeAspect="1"/>
-          </p:cNvPicPr>
-          <p:nvPr/>
-        </p:nvPicPr>
-        <p:blipFill>
-          <a:blip r:embed="rId5"/>
-          <a:stretch>
-            <a:fillRect/>
-          </a:stretch>
-        </p:blipFill>
-        <p:spPr>
-          <a:xfrm>
-            <a:off x="4323855" y="4736429"/>
-            <a:ext cx="713232" cy="539821"/>
-          </a:xfrm>
-          <a:prstGeom prst="rect">
-            <a:avLst/>
-          </a:prstGeom>
-        </p:spPr>
-      </p:pic>
-      <p:sp>
-        <p:nvSpPr>
-          <p:cNvPr id="19" name="Text 12"/>
-          <p:cNvSpPr txBox="1"/>
-          <p:nvPr/>
-        </p:nvSpPr>
-        <p:spPr>
-          <a:xfrm>
-            <a:off x="3379394" y="6035040"/>
-            <a:ext cx="2602154" cy="228600"/>
-          </a:xfrm>
-          <a:prstGeom prst="rect">
-            <a:avLst/>
-          </a:prstGeom>
-          <a:noFill/>
-          <a:ln/>
-        </p:spPr>
-        <p:txBody>
-          <a:bodyPr wrap="square" lIns="0" tIns="0" rIns="0" bIns="0" rtlCol="0" anchor="t"/>
-          <a:lstStyle/>
-          <a:p>
-            <a:pPr indent="0" marL="0">
-              <a:buNone/>
-            </a:pPr>
-            <a:r>
-              <a:rPr lang="en-US" sz="950" b="1" spc="150" kern="0" dirty="0">
-                <a:solidFill>
-                  <a:schemeClr val="accent3"/>
-                </a:solidFill>
-                <a:latin typeface="Arial" pitchFamily="34" charset="0"/>
-                <a:ea typeface="Arial" pitchFamily="34" charset="-122"/>
-                <a:cs typeface="Arial" pitchFamily="34" charset="-120"/>
-              </a:rPr>
-              <a:t>АВАТАР: TELEGRAM, ВК, 2ГИС</a:t>
-            </a:r>
-            <a:endParaRPr lang="en-US" sz="950" dirty="0"/>
-          </a:p>
-        </p:txBody>
-      </p:sp>
-      <p:sp>
-        <p:nvSpPr>
-          <p:cNvPr id="20" name="logo-sizes"/>
-          <p:cNvSpPr/>
-          <p:nvPr/>
-        </p:nvSpPr>
-        <p:spPr>
-          <a:xfrm>
-            <a:off x="6210148" y="4069080"/>
-            <a:ext cx="2602154" cy="1874520"/>
-          </a:xfrm>
-          <a:prstGeom prst="roundRect">
-            <a:avLst>
-              <a:gd name="adj" fmla="val 2927"/>
-            </a:avLst>
-          </a:prstGeom>
-          <a:solidFill>
-            <a:schemeClr val="bg1"/>
-          </a:solidFill>
-          <a:ln w="9525">
-            <a:solidFill>
-              <a:schemeClr val="accent4"/>
-            </a:solidFill>
-            <a:prstDash val="solid"/>
-          </a:ln>
-        </p:spPr>
-      </p:sp>
-      <p:pic>
-        <p:nvPicPr>
-          <p:cNvPr id="21" name="Image 5" descr="Знак 64 px">    </p:cNvPr>
-          <p:cNvPicPr>
-            <a:picLocks noChangeAspect="1"/>
-          </p:cNvPicPr>
-          <p:nvPr/>
-        </p:nvPicPr>
-        <p:blipFill>
-          <a:blip r:embed="rId6"/>
-          <a:stretch>
-            <a:fillRect/>
-          </a:stretch>
-        </p:blipFill>
-        <p:spPr>
-          <a:xfrm>
-            <a:off x="6530188" y="4589209"/>
-            <a:ext cx="822960" cy="622871"/>
-          </a:xfrm>
-          <a:prstGeom prst="rect">
-            <a:avLst/>
-          </a:prstGeom>
-        </p:spPr>
-      </p:pic>
-      <p:sp>
-        <p:nvSpPr>
-          <p:cNvPr id="22" name="Text 14"/>
-          <p:cNvSpPr txBox="1"/>
-          <p:nvPr/>
-        </p:nvSpPr>
-        <p:spPr>
-          <a:xfrm>
-            <a:off x="6438748" y="5285232"/>
-            <a:ext cx="1005840" cy="228600"/>
-          </a:xfrm>
-          <a:prstGeom prst="rect">
-            <a:avLst/>
-          </a:prstGeom>
-          <a:noFill/>
-          <a:ln/>
-        </p:spPr>
-        <p:txBody>
-          <a:bodyPr wrap="square" lIns="0" tIns="0" rIns="0" bIns="0" rtlCol="0" anchor="t"/>
-          <a:lstStyle/>
-          <a:p>
-            <a:pPr algn="ctr" indent="0" marL="0">
-              <a:buNone/>
-            </a:pPr>
-            <a:r>
-              <a:rPr lang="en-US" sz="950" dirty="0">
-                <a:solidFill>
-                  <a:schemeClr val="accent3"/>
-                </a:solidFill>
-                <a:latin typeface="Arial" pitchFamily="34" charset="0"/>
-                <a:ea typeface="Arial" pitchFamily="34" charset="-122"/>
-                <a:cs typeface="Arial" pitchFamily="34" charset="-120"/>
-              </a:rPr>
-              <a:t>64 px</a:t>
-            </a:r>
-            <a:endParaRPr lang="en-US" sz="950" dirty="0"/>
-          </a:p>
-        </p:txBody>
-      </p:sp>
-      <p:pic>
-        <p:nvPicPr>
-          <p:cNvPr id="23" name="Image 6" descr="Знак 32">    </p:cNvPr>
-          <p:cNvPicPr>
-            <a:picLocks noChangeAspect="1"/>
-          </p:cNvPicPr>
-          <p:nvPr/>
-        </p:nvPicPr>
-        <p:blipFill>
-          <a:blip r:embed="rId7"/>
-          <a:stretch>
-            <a:fillRect/>
-          </a:stretch>
-        </p:blipFill>
-        <p:spPr>
-          <a:xfrm>
-            <a:off x="7627468" y="4900645"/>
-            <a:ext cx="411480" cy="311435"/>
-          </a:xfrm>
-          <a:prstGeom prst="rect">
-            <a:avLst/>
-          </a:prstGeom>
-        </p:spPr>
-      </p:pic>
-      <p:sp>
-        <p:nvSpPr>
-          <p:cNvPr id="24" name="Text 15"/>
-          <p:cNvSpPr txBox="1"/>
-          <p:nvPr/>
-        </p:nvSpPr>
-        <p:spPr>
-          <a:xfrm>
-            <a:off x="7536028" y="5285232"/>
-            <a:ext cx="594360" cy="228600"/>
-          </a:xfrm>
-          <a:prstGeom prst="rect">
-            <a:avLst/>
-          </a:prstGeom>
-          <a:noFill/>
-          <a:ln/>
-        </p:spPr>
-        <p:txBody>
-          <a:bodyPr wrap="square" lIns="0" tIns="0" rIns="0" bIns="0" rtlCol="0" anchor="t"/>
-          <a:lstStyle/>
-          <a:p>
-            <a:pPr algn="ctr" indent="0" marL="0">
-              <a:buNone/>
-            </a:pPr>
-            <a:r>
-              <a:rPr lang="en-US" sz="950" dirty="0">
-                <a:solidFill>
-                  <a:schemeClr val="accent3"/>
-                </a:solidFill>
-                <a:latin typeface="Arial" pitchFamily="34" charset="0"/>
-                <a:ea typeface="Arial" pitchFamily="34" charset="-122"/>
-                <a:cs typeface="Arial" pitchFamily="34" charset="-120"/>
-              </a:rPr>
-              <a:t>32</a:t>
-            </a:r>
-            <a:endParaRPr lang="en-US" sz="950" dirty="0"/>
-          </a:p>
-        </p:txBody>
-      </p:sp>
-      <p:pic>
-        <p:nvPicPr>
-          <p:cNvPr id="25" name="Image 7" descr="Знак 16">    </p:cNvPr>
-          <p:cNvPicPr>
-            <a:picLocks noChangeAspect="1"/>
-          </p:cNvPicPr>
-          <p:nvPr/>
-        </p:nvPicPr>
-        <p:blipFill>
-          <a:blip r:embed="rId8"/>
-          <a:stretch>
-            <a:fillRect/>
-          </a:stretch>
-        </p:blipFill>
-        <p:spPr>
-          <a:xfrm>
-            <a:off x="8313268" y="5045981"/>
-            <a:ext cx="219456" cy="166099"/>
-          </a:xfrm>
-          <a:prstGeom prst="rect">
-            <a:avLst/>
-          </a:prstGeom>
-        </p:spPr>
-      </p:pic>
-      <p:sp>
-        <p:nvSpPr>
-          <p:cNvPr id="26" name="Text 16"/>
-          <p:cNvSpPr txBox="1"/>
-          <p:nvPr/>
-        </p:nvSpPr>
-        <p:spPr>
-          <a:xfrm>
-            <a:off x="8221828" y="5285232"/>
-            <a:ext cx="402336" cy="228600"/>
-          </a:xfrm>
-          <a:prstGeom prst="rect">
-            <a:avLst/>
-          </a:prstGeom>
-          <a:noFill/>
-          <a:ln/>
-        </p:spPr>
-        <p:txBody>
-          <a:bodyPr wrap="square" lIns="0" tIns="0" rIns="0" bIns="0" rtlCol="0" anchor="t"/>
-          <a:lstStyle/>
-          <a:p>
-            <a:pPr algn="ctr" indent="0" marL="0">
-              <a:buNone/>
-            </a:pPr>
-            <a:r>
-              <a:rPr lang="en-US" sz="950" dirty="0">
-                <a:solidFill>
-                  <a:schemeClr val="accent3"/>
-                </a:solidFill>
-                <a:latin typeface="Arial" pitchFamily="34" charset="0"/>
-                <a:ea typeface="Arial" pitchFamily="34" charset="-122"/>
-                <a:cs typeface="Arial" pitchFamily="34" charset="-120"/>
-              </a:rPr>
-              <a:t>16</a:t>
-            </a:r>
-            <a:endParaRPr lang="en-US" sz="950" dirty="0"/>
-          </a:p>
-        </p:txBody>
-      </p:sp>
-      <p:sp>
-        <p:nvSpPr>
-          <p:cNvPr id="27" name="Text 17"/>
-          <p:cNvSpPr txBox="1"/>
-          <p:nvPr/>
-        </p:nvSpPr>
-        <p:spPr>
-          <a:xfrm>
-            <a:off x="6210148" y="6035040"/>
-            <a:ext cx="2602154" cy="228600"/>
-          </a:xfrm>
-          <a:prstGeom prst="rect">
-            <a:avLst/>
-          </a:prstGeom>
-          <a:noFill/>
-          <a:ln/>
-        </p:spPr>
-        <p:txBody>
-          <a:bodyPr wrap="square" lIns="0" tIns="0" rIns="0" bIns="0" rtlCol="0" anchor="t"/>
-          <a:lstStyle/>
-          <a:p>
-            <a:pPr indent="0" marL="0">
-              <a:buNone/>
-            </a:pPr>
-            <a:r>
-              <a:rPr lang="en-US" sz="950" b="1" spc="150" kern="0" dirty="0">
-                <a:solidFill>
-                  <a:schemeClr val="accent3"/>
-                </a:solidFill>
-                <a:latin typeface="Arial" pitchFamily="34" charset="0"/>
-                <a:ea typeface="Arial" pitchFamily="34" charset="-122"/>
-                <a:cs typeface="Arial" pitchFamily="34" charset="-120"/>
-              </a:rPr>
-              <a:t>ЗНАК ОТДЕЛЬНО, МИН. 16 PX</a:t>
-            </a:r>
-            <a:endParaRPr lang="en-US" sz="950" dirty="0"/>
-          </a:p>
-        </p:txBody>
-      </p:sp>
-      <p:sp>
-        <p:nvSpPr>
-          <p:cNvPr id="28" name="logo-colors"/>
-          <p:cNvSpPr/>
-          <p:nvPr/>
-        </p:nvSpPr>
-        <p:spPr>
-          <a:xfrm>
-            <a:off x="9040901" y="4069080"/>
-            <a:ext cx="2602154" cy="1874520"/>
-          </a:xfrm>
-          <a:prstGeom prst="roundRect">
-            <a:avLst>
-              <a:gd name="adj" fmla="val 2927"/>
-            </a:avLst>
-          </a:prstGeom>
-          <a:solidFill>
-            <a:schemeClr val="bg1"/>
-          </a:solidFill>
-          <a:ln w="9525">
-            <a:solidFill>
-              <a:schemeClr val="accent4"/>
-            </a:solidFill>
-            <a:prstDash val="solid"/>
-          </a:ln>
-        </p:spPr>
-      </p:sp>
-      <p:sp>
-        <p:nvSpPr>
-          <p:cNvPr id="29" name="Text 19"/>
-          <p:cNvSpPr txBox="1"/>
-          <p:nvPr/>
-        </p:nvSpPr>
-        <p:spPr>
-          <a:xfrm>
-            <a:off x="9269501" y="4233672"/>
-            <a:ext cx="2144954" cy="274320"/>
-          </a:xfrm>
-          <a:prstGeom prst="rect">
-            <a:avLst/>
-          </a:prstGeom>
-          <a:noFill/>
-          <a:ln/>
-        </p:spPr>
-        <p:txBody>
-          <a:bodyPr wrap="square" lIns="0" tIns="0" rIns="0" bIns="0" rtlCol="0" anchor="t"/>
-          <a:lstStyle/>
-          <a:p>
-            <a:pPr indent="0" marL="0">
-              <a:buNone/>
-            </a:pPr>
-            <a:r>
-              <a:rPr lang="en-US" sz="1300" b="1" dirty="0">
-                <a:solidFill>
-                  <a:schemeClr val="tx1"/>
-                </a:solidFill>
-                <a:latin typeface="Arial" pitchFamily="34" charset="0"/>
-                <a:ea typeface="Arial" pitchFamily="34" charset="-122"/>
-                <a:cs typeface="Arial" pitchFamily="34" charset="-120"/>
-              </a:rPr>
-              <a:t>Цвета</a:t>
-            </a:r>
-            <a:endParaRPr lang="en-US" sz="1300" dirty="0"/>
-          </a:p>
-        </p:txBody>
-      </p:sp>
-      <p:sp>
-        <p:nvSpPr>
-          <p:cNvPr id="30" name="Shape 20"/>
-          <p:cNvSpPr/>
-          <p:nvPr/>
-        </p:nvSpPr>
-        <p:spPr>
-          <a:xfrm>
-            <a:off x="9269501" y="4572000"/>
-            <a:ext cx="219456" cy="219456"/>
-          </a:xfrm>
-          <a:prstGeom prst="roundRect">
-            <a:avLst>
-              <a:gd name="adj" fmla="val 16667"/>
-            </a:avLst>
-          </a:prstGeom>
-          <a:solidFill>
-            <a:schemeClr val="accent1"/>
-          </a:solidFill>
-          <a:ln w="6350">
-            <a:solidFill>
-              <a:schemeClr val="accent4"/>
-            </a:solidFill>
-            <a:prstDash val="solid"/>
-          </a:ln>
-        </p:spPr>
-      </p:sp>
-      <p:sp>
-        <p:nvSpPr>
-          <p:cNvPr id="31" name="Text 21"/>
-          <p:cNvSpPr txBox="1"/>
-          <p:nvPr/>
-        </p:nvSpPr>
-        <p:spPr>
-          <a:xfrm>
-            <a:off x="9589541" y="4553712"/>
-            <a:ext cx="1870634" cy="256032"/>
-          </a:xfrm>
-          <a:prstGeom prst="rect">
-            <a:avLst/>
-          </a:prstGeom>
-          <a:noFill/>
-          <a:ln/>
-        </p:spPr>
-        <p:txBody>
-          <a:bodyPr wrap="square" lIns="0" tIns="0" rIns="0" bIns="0" rtlCol="0" anchor="ctr"/>
-          <a:lstStyle/>
-          <a:p>
-            <a:pPr indent="0" marL="0">
-              <a:buNone/>
-            </a:pPr>
-            <a:r>
-              <a:rPr lang="en-US" sz="1100" dirty="0">
-                <a:solidFill>
-                  <a:schemeClr val="accent3"/>
-                </a:solidFill>
-                <a:latin typeface="Arial" pitchFamily="34" charset="0"/>
-                <a:ea typeface="Arial" pitchFamily="34" charset="-122"/>
-                <a:cs typeface="Arial" pitchFamily="34" charset="-120"/>
-              </a:rPr>
-              <a:t>Бордо #7B1E2E</a:t>
-            </a:r>
-            <a:endParaRPr lang="en-US" sz="1100" dirty="0"/>
-          </a:p>
-        </p:txBody>
-      </p:sp>
-      <p:sp>
-        <p:nvSpPr>
-          <p:cNvPr id="32" name="Shape 22"/>
-          <p:cNvSpPr/>
-          <p:nvPr/>
-        </p:nvSpPr>
-        <p:spPr>
-          <a:xfrm>
-            <a:off x="9269501" y="4864608"/>
-            <a:ext cx="219456" cy="219456"/>
-          </a:xfrm>
-          <a:prstGeom prst="roundRect">
-            <a:avLst>
-              <a:gd name="adj" fmla="val 16667"/>
-            </a:avLst>
-          </a:prstGeom>
-          <a:solidFill>
-            <a:schemeClr val="tx2"/>
-          </a:solidFill>
-          <a:ln w="6350">
-            <a:solidFill>
-              <a:schemeClr val="accent4"/>
-            </a:solidFill>
-            <a:prstDash val="solid"/>
-          </a:ln>
-        </p:spPr>
-      </p:sp>
-      <p:sp>
-        <p:nvSpPr>
-          <p:cNvPr id="33" name="Text 23"/>
-          <p:cNvSpPr txBox="1"/>
-          <p:nvPr/>
-        </p:nvSpPr>
-        <p:spPr>
-          <a:xfrm>
-            <a:off x="9589541" y="4846320"/>
-            <a:ext cx="1870634" cy="256032"/>
-          </a:xfrm>
-          <a:prstGeom prst="rect">
-            <a:avLst/>
-          </a:prstGeom>
-          <a:noFill/>
-          <a:ln/>
-        </p:spPr>
-        <p:txBody>
-          <a:bodyPr wrap="square" lIns="0" tIns="0" rIns="0" bIns="0" rtlCol="0" anchor="ctr"/>
-          <a:lstStyle/>
-          <a:p>
-            <a:pPr indent="0" marL="0">
-              <a:buNone/>
-            </a:pPr>
-            <a:r>
-              <a:rPr lang="en-US" sz="1100" dirty="0">
-                <a:solidFill>
-                  <a:schemeClr val="accent3"/>
-                </a:solidFill>
-                <a:latin typeface="Arial" pitchFamily="34" charset="0"/>
-                <a:ea typeface="Arial" pitchFamily="34" charset="-122"/>
-                <a:cs typeface="Arial" pitchFamily="34" charset="-120"/>
-              </a:rPr>
-              <a:t>Графит #25272B</a:t>
-            </a:r>
-            <a:endParaRPr lang="en-US" sz="1100" dirty="0"/>
-          </a:p>
-        </p:txBody>
-      </p:sp>
-      <p:sp>
-        <p:nvSpPr>
-          <p:cNvPr id="34" name="Shape 24"/>
-          <p:cNvSpPr/>
-          <p:nvPr/>
-        </p:nvSpPr>
-        <p:spPr>
-          <a:xfrm>
-            <a:off x="9269501" y="5157216"/>
-            <a:ext cx="219456" cy="219456"/>
-          </a:xfrm>
-          <a:prstGeom prst="roundRect">
-            <a:avLst>
-              <a:gd name="adj" fmla="val 16667"/>
-            </a:avLst>
-          </a:prstGeom>
-          <a:solidFill>
-            <a:schemeClr val="bg2"/>
-          </a:solidFill>
-          <a:ln w="6350">
-            <a:solidFill>
-              <a:schemeClr val="accent4"/>
-            </a:solidFill>
-            <a:prstDash val="solid"/>
-          </a:ln>
-        </p:spPr>
-      </p:sp>
-      <p:sp>
-        <p:nvSpPr>
-          <p:cNvPr id="35" name="Text 25"/>
-          <p:cNvSpPr txBox="1"/>
-          <p:nvPr/>
-        </p:nvSpPr>
-        <p:spPr>
-          <a:xfrm>
-            <a:off x="9589541" y="5138928"/>
-            <a:ext cx="1870634" cy="256032"/>
-          </a:xfrm>
-          <a:prstGeom prst="rect">
-            <a:avLst/>
-          </a:prstGeom>
-          <a:noFill/>
-          <a:ln/>
-        </p:spPr>
-        <p:txBody>
-          <a:bodyPr wrap="square" lIns="0" tIns="0" rIns="0" bIns="0" rtlCol="0" anchor="ctr"/>
-          <a:lstStyle/>
-          <a:p>
-            <a:pPr indent="0" marL="0">
-              <a:buNone/>
-            </a:pPr>
-            <a:r>
-              <a:rPr lang="en-US" sz="1100" dirty="0">
-                <a:solidFill>
-                  <a:schemeClr val="accent3"/>
-                </a:solidFill>
-                <a:latin typeface="Arial" pitchFamily="34" charset="0"/>
-                <a:ea typeface="Arial" pitchFamily="34" charset="-122"/>
-                <a:cs typeface="Arial" pitchFamily="34" charset="-120"/>
-              </a:rPr>
-              <a:t>Светлый #F7F6F4</a:t>
-            </a:r>
-            <a:endParaRPr lang="en-US" sz="1100" dirty="0"/>
-          </a:p>
-        </p:txBody>
-      </p:sp>
-      <p:sp>
-        <p:nvSpPr>
-          <p:cNvPr id="36" name="Text 26"/>
-          <p:cNvSpPr txBox="1"/>
-          <p:nvPr/>
-        </p:nvSpPr>
-        <p:spPr>
-          <a:xfrm>
-            <a:off x="9269501" y="5440680"/>
-            <a:ext cx="2144954" cy="411480"/>
-          </a:xfrm>
-          <a:prstGeom prst="rect">
-            <a:avLst/>
-          </a:prstGeom>
-          <a:noFill/>
-          <a:ln/>
-        </p:spPr>
-        <p:txBody>
-          <a:bodyPr wrap="square" lIns="0" tIns="0" rIns="0" bIns="0" rtlCol="0" anchor="t"/>
-          <a:lstStyle/>
-          <a:p>
-            <a:pPr indent="0" marL="0">
-              <a:buNone/>
-            </a:pPr>
-            <a:r>
-              <a:rPr lang="en-US" sz="1000" dirty="0">
-                <a:solidFill>
-                  <a:schemeClr val="accent3"/>
-                </a:solidFill>
-                <a:latin typeface="Arial" pitchFamily="34" charset="0"/>
-                <a:ea typeface="Arial" pitchFamily="34" charset="-122"/>
-                <a:cs typeface="Arial" pitchFamily="34" charset="-120"/>
-              </a:rPr>
-              <a:t>Охранное поле вокруг логотипа — не меньше высоты буквы.</a:t>
-            </a:r>
-            <a:endParaRPr lang="en-US" sz="1000" dirty="0"/>
-          </a:p>
-        </p:txBody>
-      </p:sp>
-      <p:sp>
-        <p:nvSpPr>
-          <p:cNvPr id="25" name="Slide Number Placeholder 0"/>
-          <p:cNvSpPr>
-            <a:spLocks noGrp="1"/>
-          </p:cNvSpPr>
-          <p:nvPr>
-            <p:ph type="sldNum" sz="quarter" idx="4294967295"/>
-          </p:nvPr>
-        </p:nvSpPr>
-        <p:spPr>
-          <a:xfrm>
-            <a:off x="10911535" y="6400800"/>
-            <a:ext cx="731520" cy="274320"/>
-          </a:xfrm>
-          <a:prstGeom prst="rect">
-            <a:avLst/>
-          </a:prstGeom>
-          <a:extLst>
-            <a:ext uri="{C572A759-6A51-4108-AA02-DFA0A04FC94B}">
-              <ma14:wrappingTextBoxFlag xmlns:ma14="http://schemas.microsoft.com/office/mac/drawingml/2011/main" val="0"/>
-            </a:ext>
-          </a:extLst>
-        </p:spPr>
-        <p:txBody>
-          <a:bodyPr/>
-          <a:lstStyle>
-            <a:lvl1pPr>
-              <a:defRPr sz="1000">
-                <a:solidFill>
-                  <a:schemeClr val="accent3"/>
-                </a:solidFill>
-              </a:defRPr>
-            </a:lvl1pPr>
-          </a:lstStyle>
-          <a:p>
-            <a:pPr algn="r"/>
-            <a:fld id="{F7021451-1387-4CA6-816F-3879F97B5CBC}" type="slidenum">
-              <a:rPr b="0" lang="en-US"/>
-              <a:t>9</a:t>
             </a:fld>
             <a:endParaRPr lang="en-US"/>
           </a:p>

</xml_diff>